<commit_message>
Rename fixed class deck files
</commit_message>
<xml_diff>
--- a/class/3일차_5.pptx
+++ b/class/3일차_5.pptx
@@ -6,24 +6,26 @@
     <p:sldMasterId id="2147483650" r:id="rId2"/>
   </p:sldMasterIdLst>
   <p:notesMasterIdLst>
-    <p:notesMasterId r:id="rId18"/>
+    <p:notesMasterId r:id="rId20"/>
   </p:notesMasterIdLst>
   <p:sldIdLst>
     <p:sldId id="291" r:id="rId3"/>
-    <p:sldId id="257" r:id="rId4"/>
-    <p:sldId id="258" r:id="rId5"/>
-    <p:sldId id="259" r:id="rId6"/>
-    <p:sldId id="260" r:id="rId7"/>
-    <p:sldId id="261" r:id="rId8"/>
-    <p:sldId id="262" r:id="rId9"/>
-    <p:sldId id="263" r:id="rId10"/>
-    <p:sldId id="264" r:id="rId11"/>
-    <p:sldId id="265" r:id="rId12"/>
-    <p:sldId id="266" r:id="rId13"/>
-    <p:sldId id="267" r:id="rId14"/>
-    <p:sldId id="268" r:id="rId15"/>
-    <p:sldId id="274" r:id="rId16"/>
-    <p:sldId id="292" r:id="rId17"/>
+    <p:sldId id="294" r:id="rId4"/>
+    <p:sldId id="257" r:id="rId5"/>
+    <p:sldId id="258" r:id="rId6"/>
+    <p:sldId id="259" r:id="rId7"/>
+    <p:sldId id="260" r:id="rId8"/>
+    <p:sldId id="261" r:id="rId9"/>
+    <p:sldId id="262" r:id="rId10"/>
+    <p:sldId id="263" r:id="rId11"/>
+    <p:sldId id="264" r:id="rId12"/>
+    <p:sldId id="265" r:id="rId13"/>
+    <p:sldId id="266" r:id="rId14"/>
+    <p:sldId id="267" r:id="rId15"/>
+    <p:sldId id="268" r:id="rId16"/>
+    <p:sldId id="295" r:id="rId17"/>
+    <p:sldId id="274" r:id="rId18"/>
+    <p:sldId id="292" r:id="rId19"/>
   </p:sldIdLst>
   <p:sldSz cx="12192000" cy="6858000"/>
   <p:notesSz cx="6858000" cy="12192000"/>
@@ -446,7 +448,7 @@
           <a:p>
             <a:fld id="{F7021451-1387-4CA6-816F-3879F97B5CBC}" type="slidenum">
               <a:rPr lang="en-US"/>
-              <a:t>10</a:t>
+              <a:t>11</a:t>
             </a:fld>
             <a:endParaRPr lang="en-US"/>
           </a:p>
@@ -530,7 +532,7 @@
           <a:p>
             <a:fld id="{F7021451-1387-4CA6-816F-3879F97B5CBC}" type="slidenum">
               <a:rPr lang="en-US"/>
-              <a:t>11</a:t>
+              <a:t>12</a:t>
             </a:fld>
             <a:endParaRPr lang="en-US"/>
           </a:p>
@@ -614,7 +616,7 @@
           <a:p>
             <a:fld id="{F7021451-1387-4CA6-816F-3879F97B5CBC}" type="slidenum">
               <a:rPr lang="en-US"/>
-              <a:t>12</a:t>
+              <a:t>13</a:t>
             </a:fld>
             <a:endParaRPr lang="en-US"/>
           </a:p>
@@ -698,7 +700,7 @@
           <a:p>
             <a:fld id="{F7021451-1387-4CA6-816F-3879F97B5CBC}" type="slidenum">
               <a:rPr lang="en-US"/>
-              <a:t>13</a:t>
+              <a:t>14</a:t>
             </a:fld>
             <a:endParaRPr lang="en-US"/>
           </a:p>
@@ -782,7 +784,7 @@
           <a:p>
             <a:fld id="{F7021451-1387-4CA6-816F-3879F97B5CBC}" type="slidenum">
               <a:rPr lang="en-US"/>
-              <a:t>14</a:t>
+              <a:t>16</a:t>
             </a:fld>
             <a:endParaRPr lang="en-US"/>
           </a:p>
@@ -995,7 +997,7 @@
           <a:p>
             <a:fld id="{F7021451-1387-4CA6-816F-3879F97B5CBC}" type="slidenum">
               <a:rPr lang="en-US"/>
-              <a:t>2</a:t>
+              <a:t>3</a:t>
             </a:fld>
             <a:endParaRPr lang="en-US"/>
           </a:p>
@@ -1079,7 +1081,7 @@
           <a:p>
             <a:fld id="{F7021451-1387-4CA6-816F-3879F97B5CBC}" type="slidenum">
               <a:rPr lang="en-US"/>
-              <a:t>3</a:t>
+              <a:t>4</a:t>
             </a:fld>
             <a:endParaRPr lang="en-US"/>
           </a:p>
@@ -1163,7 +1165,7 @@
           <a:p>
             <a:fld id="{F7021451-1387-4CA6-816F-3879F97B5CBC}" type="slidenum">
               <a:rPr lang="en-US"/>
-              <a:t>4</a:t>
+              <a:t>5</a:t>
             </a:fld>
             <a:endParaRPr lang="en-US"/>
           </a:p>
@@ -1247,7 +1249,7 @@
           <a:p>
             <a:fld id="{F7021451-1387-4CA6-816F-3879F97B5CBC}" type="slidenum">
               <a:rPr lang="en-US"/>
-              <a:t>5</a:t>
+              <a:t>6</a:t>
             </a:fld>
             <a:endParaRPr lang="en-US"/>
           </a:p>
@@ -1331,7 +1333,7 @@
           <a:p>
             <a:fld id="{F7021451-1387-4CA6-816F-3879F97B5CBC}" type="slidenum">
               <a:rPr lang="en-US"/>
-              <a:t>6</a:t>
+              <a:t>7</a:t>
             </a:fld>
             <a:endParaRPr lang="en-US"/>
           </a:p>
@@ -1415,7 +1417,7 @@
           <a:p>
             <a:fld id="{F7021451-1387-4CA6-816F-3879F97B5CBC}" type="slidenum">
               <a:rPr lang="en-US"/>
-              <a:t>7</a:t>
+              <a:t>8</a:t>
             </a:fld>
             <a:endParaRPr lang="en-US"/>
           </a:p>
@@ -1499,7 +1501,7 @@
           <a:p>
             <a:fld id="{F7021451-1387-4CA6-816F-3879F97B5CBC}" type="slidenum">
               <a:rPr lang="en-US"/>
-              <a:t>8</a:t>
+              <a:t>9</a:t>
             </a:fld>
             <a:endParaRPr lang="en-US"/>
           </a:p>
@@ -1583,7 +1585,7 @@
           <a:p>
             <a:fld id="{F7021451-1387-4CA6-816F-3879F97B5CBC}" type="slidenum">
               <a:rPr lang="en-US"/>
-              <a:t>9</a:t>
+              <a:t>10</a:t>
             </a:fld>
             <a:endParaRPr lang="en-US"/>
           </a:p>
@@ -8906,31 +8908,7 @@
                 <a:cs typeface="Calibri Light" pitchFamily="34" charset="-120"/>
                 <a:sym typeface="Arial"/>
               </a:rPr>
-              <a:t>실습</a:t>
-            </a:r>
-            <a:r>
-              <a:rPr lang="en-US" altLang="ko-KR" sz="3200" b="1" dirty="0">
-                <a:solidFill>
-                  <a:srgbClr val="FFFFFF"/>
-                </a:solidFill>
-                <a:latin typeface="Calibri Light" pitchFamily="34" charset="0"/>
-                <a:ea typeface="Arial"/>
-                <a:cs typeface="Calibri Light" pitchFamily="34" charset="-120"/>
-                <a:sym typeface="Arial"/>
-              </a:rPr>
-              <a:t>3:</a:t>
-            </a:r>
-            <a:r>
-              <a:rPr lang="ko-KR" altLang="en-US" sz="3200" b="1" dirty="0">
-                <a:solidFill>
-                  <a:srgbClr val="FFFFFF"/>
-                </a:solidFill>
-                <a:latin typeface="Calibri Light" pitchFamily="34" charset="0"/>
-                <a:ea typeface="Arial"/>
-                <a:cs typeface="Calibri Light" pitchFamily="34" charset="-120"/>
-                <a:sym typeface="Arial"/>
-              </a:rPr>
-              <a:t> 오픈소스 활용 </a:t>
+              <a:t>오픈소스 활용 </a:t>
             </a:r>
             <a:r>
               <a:rPr lang="en-US" altLang="ko-KR" sz="3200" b="1" dirty="0">
@@ -9181,6 +9159,1403 @@
 </file>
 
 <file path=ppt/slides/slide10.xml><?xml version="1.0" encoding="utf-8"?>
+<p:sld xmlns:a="http://schemas.openxmlformats.org/drawingml/2006/main" xmlns:r="http://schemas.openxmlformats.org/officeDocument/2006/relationships" xmlns:p="http://schemas.openxmlformats.org/presentationml/2006/main">
+  <p:cSld name="Slide 9">
+    <p:bg>
+      <p:bgPr>
+        <a:solidFill>
+          <a:srgbClr val="FFFFFF"/>
+        </a:solidFill>
+        <a:effectLst/>
+      </p:bgPr>
+    </p:bg>
+    <p:spTree>
+      <p:nvGrpSpPr>
+        <p:cNvPr id="1" name=""/>
+        <p:cNvGrpSpPr/>
+        <p:nvPr/>
+      </p:nvGrpSpPr>
+      <p:grpSpPr>
+        <a:xfrm>
+          <a:off x="0" y="0"/>
+          <a:ext cx="0" cy="0"/>
+          <a:chOff x="0" y="0"/>
+          <a:chExt cx="0" cy="0"/>
+        </a:xfrm>
+      </p:grpSpPr>
+      <p:sp>
+        <p:nvSpPr>
+          <p:cNvPr id="2" name="Text 0"/>
+          <p:cNvSpPr/>
+          <p:nvPr/>
+        </p:nvSpPr>
+        <p:spPr>
+          <a:xfrm>
+            <a:off x="365760" y="228600"/>
+            <a:ext cx="10972800" cy="365760"/>
+          </a:xfrm>
+          <a:prstGeom prst="rect">
+            <a:avLst/>
+          </a:prstGeom>
+          <a:noFill/>
+          <a:ln/>
+        </p:spPr>
+        <p:txBody>
+          <a:bodyPr wrap="square" lIns="0" tIns="0" rIns="0" bIns="0" rtlCol="0" anchor="ctr"/>
+          <a:lstStyle/>
+          <a:p>
+            <a:pPr marL="0" indent="0">
+              <a:buNone/>
+            </a:pPr>
+            <a:r>
+              <a:rPr lang="en-US" sz="1500" b="1" dirty="0">
+                <a:solidFill>
+                  <a:srgbClr val="111848"/>
+                </a:solidFill>
+                <a:latin typeface="Arial" pitchFamily="34" charset="0"/>
+                <a:ea typeface="Arial" pitchFamily="34" charset="-122"/>
+                <a:cs typeface="Arial" pitchFamily="34" charset="-120"/>
+              </a:rPr>
+              <a:t>🎯 Step B-1 — eval 엔트리 파싱 (프로브별 PASS/FAIL 요약)</a:t>
+            </a:r>
+            <a:endParaRPr lang="en-US" sz="1500" dirty="0"/>
+          </a:p>
+        </p:txBody>
+      </p:sp>
+      <p:sp>
+        <p:nvSpPr>
+          <p:cNvPr id="3" name="Shape 1"/>
+          <p:cNvSpPr/>
+          <p:nvPr/>
+        </p:nvSpPr>
+        <p:spPr>
+          <a:xfrm>
+            <a:off x="274320" y="548640"/>
+            <a:ext cx="11612880" cy="36576"/>
+          </a:xfrm>
+          <a:prstGeom prst="rect">
+            <a:avLst/>
+          </a:prstGeom>
+          <a:solidFill>
+            <a:srgbClr val="7C3AED"/>
+          </a:solidFill>
+          <a:ln w="12700">
+            <a:solidFill>
+              <a:srgbClr val="333333"/>
+            </a:solidFill>
+            <a:prstDash val="solid"/>
+          </a:ln>
+        </p:spPr>
+        <p:txBody>
+          <a:bodyPr/>
+          <a:lstStyle/>
+          <a:p>
+            <a:endParaRPr lang="ko-KR" altLang="en-US"/>
+          </a:p>
+        </p:txBody>
+      </p:sp>
+      <p:sp>
+        <p:nvSpPr>
+          <p:cNvPr id="4" name="Shape 2"/>
+          <p:cNvSpPr/>
+          <p:nvPr/>
+        </p:nvSpPr>
+        <p:spPr>
+          <a:xfrm>
+            <a:off x="274320" y="640080"/>
+            <a:ext cx="5303520" cy="1417320"/>
+          </a:xfrm>
+          <a:prstGeom prst="rect">
+            <a:avLst/>
+          </a:prstGeom>
+          <a:solidFill>
+            <a:srgbClr val="FFFFFF"/>
+          </a:solidFill>
+          <a:ln w="15240">
+            <a:solidFill>
+              <a:srgbClr val="7C3AED"/>
+            </a:solidFill>
+            <a:prstDash val="solid"/>
+          </a:ln>
+          <a:effectLst>
+            <a:outerShdw blurRad="63500" dist="25400" dir="8100000" algn="bl" rotWithShape="0">
+              <a:srgbClr val="000000">
+                <a:alpha val="10000"/>
+              </a:srgbClr>
+            </a:outerShdw>
+          </a:effectLst>
+        </p:spPr>
+        <p:txBody>
+          <a:bodyPr/>
+          <a:lstStyle/>
+          <a:p>
+            <a:endParaRPr lang="ko-KR" altLang="en-US"/>
+          </a:p>
+        </p:txBody>
+      </p:sp>
+      <p:sp>
+        <p:nvSpPr>
+          <p:cNvPr id="5" name="Shape 3"/>
+          <p:cNvSpPr/>
+          <p:nvPr/>
+        </p:nvSpPr>
+        <p:spPr>
+          <a:xfrm>
+            <a:off x="274320" y="640080"/>
+            <a:ext cx="5303520" cy="329184"/>
+          </a:xfrm>
+          <a:prstGeom prst="rect">
+            <a:avLst/>
+          </a:prstGeom>
+          <a:solidFill>
+            <a:srgbClr val="7C3AED"/>
+          </a:solidFill>
+          <a:ln w="12700">
+            <a:solidFill>
+              <a:srgbClr val="7C3AED"/>
+            </a:solidFill>
+            <a:prstDash val="solid"/>
+          </a:ln>
+        </p:spPr>
+        <p:txBody>
+          <a:bodyPr/>
+          <a:lstStyle/>
+          <a:p>
+            <a:endParaRPr lang="ko-KR" altLang="en-US"/>
+          </a:p>
+        </p:txBody>
+      </p:sp>
+      <p:sp>
+        <p:nvSpPr>
+          <p:cNvPr id="6" name="Text 4"/>
+          <p:cNvSpPr/>
+          <p:nvPr/>
+        </p:nvSpPr>
+        <p:spPr>
+          <a:xfrm>
+            <a:off x="384048" y="640080"/>
+            <a:ext cx="5084064" cy="329184"/>
+          </a:xfrm>
+          <a:prstGeom prst="rect">
+            <a:avLst/>
+          </a:prstGeom>
+          <a:noFill/>
+          <a:ln/>
+        </p:spPr>
+        <p:txBody>
+          <a:bodyPr wrap="square" lIns="0" tIns="0" rIns="0" bIns="0" rtlCol="0" anchor="ctr"/>
+          <a:lstStyle/>
+          <a:p>
+            <a:pPr marL="0" indent="0">
+              <a:buNone/>
+            </a:pPr>
+            <a:r>
+              <a:rPr lang="en-US" sz="1100" b="1" dirty="0">
+                <a:solidFill>
+                  <a:srgbClr val="FFFFFF"/>
+                </a:solidFill>
+                <a:latin typeface="Arial" pitchFamily="34" charset="0"/>
+                <a:ea typeface="Arial" pitchFamily="34" charset="-122"/>
+                <a:cs typeface="Arial" pitchFamily="34" charset="-120"/>
+              </a:rPr>
+              <a:t>JSONL 파일 위치 확인</a:t>
+            </a:r>
+            <a:endParaRPr lang="en-US" sz="1100" dirty="0"/>
+          </a:p>
+        </p:txBody>
+      </p:sp>
+      <p:sp>
+        <p:nvSpPr>
+          <p:cNvPr id="7" name="Text 5"/>
+          <p:cNvSpPr/>
+          <p:nvPr/>
+        </p:nvSpPr>
+        <p:spPr>
+          <a:xfrm>
+            <a:off x="411480" y="1042416"/>
+            <a:ext cx="5029200" cy="246888"/>
+          </a:xfrm>
+          <a:prstGeom prst="rect">
+            <a:avLst/>
+          </a:prstGeom>
+          <a:noFill/>
+          <a:ln/>
+        </p:spPr>
+        <p:txBody>
+          <a:bodyPr wrap="square" rtlCol="0" anchor="ctr"/>
+          <a:lstStyle/>
+          <a:p>
+            <a:pPr marL="0" indent="0">
+              <a:buNone/>
+            </a:pPr>
+            <a:r>
+              <a:rPr lang="en-US" sz="1000" dirty="0">
+                <a:solidFill>
+                  <a:srgbClr val="111848"/>
+                </a:solidFill>
+                <a:latin typeface="Arial" pitchFamily="34" charset="0"/>
+                <a:ea typeface="Arial" pitchFamily="34" charset="-122"/>
+                <a:cs typeface="Arial" pitchFamily="34" charset="-120"/>
+              </a:rPr>
+              <a:t>실습 A 완료 후 GARAK_RUNS 경로에 저장됨</a:t>
+            </a:r>
+            <a:endParaRPr lang="en-US" sz="1000" dirty="0"/>
+          </a:p>
+        </p:txBody>
+      </p:sp>
+      <p:sp>
+        <p:nvSpPr>
+          <p:cNvPr id="8" name="Text 6"/>
+          <p:cNvSpPr/>
+          <p:nvPr/>
+        </p:nvSpPr>
+        <p:spPr>
+          <a:xfrm>
+            <a:off x="411480" y="1316736"/>
+            <a:ext cx="5029200" cy="246888"/>
+          </a:xfrm>
+          <a:prstGeom prst="rect">
+            <a:avLst/>
+          </a:prstGeom>
+          <a:noFill/>
+          <a:ln/>
+        </p:spPr>
+        <p:txBody>
+          <a:bodyPr wrap="square" rtlCol="0" anchor="ctr"/>
+          <a:lstStyle/>
+          <a:p>
+            <a:pPr marL="0" indent="0">
+              <a:buNone/>
+            </a:pPr>
+            <a:r>
+              <a:rPr lang="en-US" sz="1000" dirty="0">
+                <a:solidFill>
+                  <a:srgbClr val="111848"/>
+                </a:solidFill>
+                <a:latin typeface="Arial" pitchFamily="34" charset="0"/>
+                <a:ea typeface="Arial" pitchFamily="34" charset="-122"/>
+                <a:cs typeface="Arial" pitchFamily="34" charset="-120"/>
+              </a:rPr>
+              <a:t>*.report.jsonl — 전체 로그</a:t>
+            </a:r>
+            <a:endParaRPr lang="en-US" sz="1000" dirty="0"/>
+          </a:p>
+        </p:txBody>
+      </p:sp>
+      <p:sp>
+        <p:nvSpPr>
+          <p:cNvPr id="9" name="Shape 7"/>
+          <p:cNvSpPr/>
+          <p:nvPr/>
+        </p:nvSpPr>
+        <p:spPr>
+          <a:xfrm>
+            <a:off x="274320" y="2176272"/>
+            <a:ext cx="5303520" cy="1417320"/>
+          </a:xfrm>
+          <a:prstGeom prst="rect">
+            <a:avLst/>
+          </a:prstGeom>
+          <a:solidFill>
+            <a:srgbClr val="FFFFFF"/>
+          </a:solidFill>
+          <a:ln w="15240">
+            <a:solidFill>
+              <a:srgbClr val="2563EB"/>
+            </a:solidFill>
+            <a:prstDash val="solid"/>
+          </a:ln>
+          <a:effectLst>
+            <a:outerShdw blurRad="63500" dist="25400" dir="8100000" algn="bl" rotWithShape="0">
+              <a:srgbClr val="000000">
+                <a:alpha val="10000"/>
+              </a:srgbClr>
+            </a:outerShdw>
+          </a:effectLst>
+        </p:spPr>
+        <p:txBody>
+          <a:bodyPr/>
+          <a:lstStyle/>
+          <a:p>
+            <a:endParaRPr lang="ko-KR" altLang="en-US" dirty="0"/>
+          </a:p>
+        </p:txBody>
+      </p:sp>
+      <p:sp>
+        <p:nvSpPr>
+          <p:cNvPr id="10" name="Shape 8"/>
+          <p:cNvSpPr/>
+          <p:nvPr/>
+        </p:nvSpPr>
+        <p:spPr>
+          <a:xfrm>
+            <a:off x="274320" y="2176272"/>
+            <a:ext cx="5303520" cy="329184"/>
+          </a:xfrm>
+          <a:prstGeom prst="rect">
+            <a:avLst/>
+          </a:prstGeom>
+          <a:solidFill>
+            <a:srgbClr val="2563EB"/>
+          </a:solidFill>
+          <a:ln w="12700">
+            <a:solidFill>
+              <a:srgbClr val="2563EB"/>
+            </a:solidFill>
+            <a:prstDash val="solid"/>
+          </a:ln>
+        </p:spPr>
+        <p:txBody>
+          <a:bodyPr/>
+          <a:lstStyle/>
+          <a:p>
+            <a:endParaRPr lang="ko-KR" altLang="en-US"/>
+          </a:p>
+        </p:txBody>
+      </p:sp>
+      <p:sp>
+        <p:nvSpPr>
+          <p:cNvPr id="11" name="Text 9"/>
+          <p:cNvSpPr/>
+          <p:nvPr/>
+        </p:nvSpPr>
+        <p:spPr>
+          <a:xfrm>
+            <a:off x="384048" y="2176272"/>
+            <a:ext cx="5084064" cy="329184"/>
+          </a:xfrm>
+          <a:prstGeom prst="rect">
+            <a:avLst/>
+          </a:prstGeom>
+          <a:noFill/>
+          <a:ln/>
+        </p:spPr>
+        <p:txBody>
+          <a:bodyPr wrap="square" lIns="0" tIns="0" rIns="0" bIns="0" rtlCol="0" anchor="ctr"/>
+          <a:lstStyle/>
+          <a:p>
+            <a:pPr marL="0" indent="0">
+              <a:buNone/>
+            </a:pPr>
+            <a:r>
+              <a:rPr lang="en-US" sz="1100" b="1" dirty="0">
+                <a:solidFill>
+                  <a:srgbClr val="FFFFFF"/>
+                </a:solidFill>
+                <a:latin typeface="Arial" pitchFamily="34" charset="0"/>
+                <a:ea typeface="Arial" pitchFamily="34" charset="-122"/>
+                <a:cs typeface="Arial" pitchFamily="34" charset="-120"/>
+              </a:rPr>
+              <a:t>분석 목표</a:t>
+            </a:r>
+            <a:endParaRPr lang="en-US" sz="1100" dirty="0"/>
+          </a:p>
+        </p:txBody>
+      </p:sp>
+      <p:sp>
+        <p:nvSpPr>
+          <p:cNvPr id="12" name="Text 10"/>
+          <p:cNvSpPr/>
+          <p:nvPr/>
+        </p:nvSpPr>
+        <p:spPr>
+          <a:xfrm>
+            <a:off x="411480" y="2578608"/>
+            <a:ext cx="5029200" cy="246888"/>
+          </a:xfrm>
+          <a:prstGeom prst="rect">
+            <a:avLst/>
+          </a:prstGeom>
+          <a:noFill/>
+          <a:ln/>
+        </p:spPr>
+        <p:txBody>
+          <a:bodyPr wrap="square" rtlCol="0" anchor="ctr"/>
+          <a:lstStyle/>
+          <a:p>
+            <a:pPr marL="0" indent="0">
+              <a:buNone/>
+            </a:pPr>
+            <a:r>
+              <a:rPr lang="en-US" sz="1000" dirty="0">
+                <a:solidFill>
+                  <a:srgbClr val="111848"/>
+                </a:solidFill>
+                <a:latin typeface="Arial" pitchFamily="34" charset="0"/>
+                <a:ea typeface="Arial" pitchFamily="34" charset="-122"/>
+                <a:cs typeface="Arial" pitchFamily="34" charset="-120"/>
+              </a:rPr>
+              <a:t>① 프로브별 PASS/FAIL 비율 집계</a:t>
+            </a:r>
+            <a:endParaRPr lang="en-US" sz="1000" dirty="0"/>
+          </a:p>
+        </p:txBody>
+      </p:sp>
+      <p:sp>
+        <p:nvSpPr>
+          <p:cNvPr id="14" name="Text 12"/>
+          <p:cNvSpPr/>
+          <p:nvPr/>
+        </p:nvSpPr>
+        <p:spPr>
+          <a:xfrm>
+            <a:off x="411480" y="3127248"/>
+            <a:ext cx="5029200" cy="246888"/>
+          </a:xfrm>
+          <a:prstGeom prst="rect">
+            <a:avLst/>
+          </a:prstGeom>
+          <a:noFill/>
+          <a:ln/>
+        </p:spPr>
+        <p:txBody>
+          <a:bodyPr wrap="square" rtlCol="0" anchor="ctr"/>
+          <a:lstStyle/>
+          <a:p>
+            <a:pPr marL="0" indent="0">
+              <a:buNone/>
+            </a:pPr>
+            <a:r>
+              <a:rPr lang="en-US" sz="1000" b="1" dirty="0">
+                <a:solidFill>
+                  <a:srgbClr val="2563EB"/>
+                </a:solidFill>
+                <a:latin typeface="Arial" pitchFamily="34" charset="0"/>
+                <a:ea typeface="Arial" pitchFamily="34" charset="-122"/>
+                <a:cs typeface="Arial" pitchFamily="34" charset="-120"/>
+              </a:rPr>
+              <a:t>→ 자동화 도구로 수동 테스트 대비 커버리지 비교</a:t>
+            </a:r>
+            <a:endParaRPr lang="en-US" sz="1000" dirty="0"/>
+          </a:p>
+        </p:txBody>
+      </p:sp>
+      <p:sp>
+        <p:nvSpPr>
+          <p:cNvPr id="15" name="Text 13"/>
+          <p:cNvSpPr/>
+          <p:nvPr/>
+        </p:nvSpPr>
+        <p:spPr>
+          <a:xfrm>
+            <a:off x="5760720" y="640080"/>
+            <a:ext cx="6126480" cy="320040"/>
+          </a:xfrm>
+          <a:prstGeom prst="rect">
+            <a:avLst/>
+          </a:prstGeom>
+          <a:noFill/>
+          <a:ln/>
+        </p:spPr>
+        <p:txBody>
+          <a:bodyPr wrap="square" rtlCol="0" anchor="ctr"/>
+          <a:lstStyle/>
+          <a:p>
+            <a:pPr marL="0" indent="0">
+              <a:buNone/>
+            </a:pPr>
+            <a:r>
+              <a:rPr lang="en-US" sz="1200" b="1" dirty="0">
+                <a:solidFill>
+                  <a:srgbClr val="111848"/>
+                </a:solidFill>
+                <a:latin typeface="Arial" pitchFamily="34" charset="0"/>
+                <a:ea typeface="Arial" pitchFamily="34" charset="-122"/>
+                <a:cs typeface="Arial" pitchFamily="34" charset="-120"/>
+              </a:rPr>
+              <a:t>Cell 15: 실행 코드</a:t>
+            </a:r>
+            <a:endParaRPr lang="en-US" sz="1200" dirty="0"/>
+          </a:p>
+        </p:txBody>
+      </p:sp>
+      <p:sp>
+        <p:nvSpPr>
+          <p:cNvPr id="16" name="Shape 14"/>
+          <p:cNvSpPr/>
+          <p:nvPr/>
+        </p:nvSpPr>
+        <p:spPr>
+          <a:xfrm>
+            <a:off x="5760720" y="1005840"/>
+            <a:ext cx="6126480" cy="4014216"/>
+          </a:xfrm>
+          <a:prstGeom prst="rect">
+            <a:avLst/>
+          </a:prstGeom>
+          <a:solidFill>
+            <a:srgbClr val="0D1117"/>
+          </a:solidFill>
+          <a:ln/>
+          <a:effectLst>
+            <a:outerShdw blurRad="63500" dist="25400" dir="8100000" algn="bl" rotWithShape="0">
+              <a:srgbClr val="000000">
+                <a:alpha val="10000"/>
+              </a:srgbClr>
+            </a:outerShdw>
+          </a:effectLst>
+        </p:spPr>
+        <p:txBody>
+          <a:bodyPr/>
+          <a:lstStyle/>
+          <a:p>
+            <a:endParaRPr lang="ko-KR" altLang="en-US" dirty="0"/>
+          </a:p>
+        </p:txBody>
+      </p:sp>
+      <p:sp>
+        <p:nvSpPr>
+          <p:cNvPr id="17" name="Text 15"/>
+          <p:cNvSpPr/>
+          <p:nvPr/>
+        </p:nvSpPr>
+        <p:spPr>
+          <a:xfrm>
+            <a:off x="5897880" y="1115568"/>
+            <a:ext cx="5852160" cy="228600"/>
+          </a:xfrm>
+          <a:prstGeom prst="rect">
+            <a:avLst/>
+          </a:prstGeom>
+          <a:noFill/>
+          <a:ln/>
+        </p:spPr>
+        <p:txBody>
+          <a:bodyPr wrap="square" lIns="0" tIns="0" rIns="0" bIns="0" rtlCol="0" anchor="ctr"/>
+          <a:lstStyle/>
+          <a:p>
+            <a:pPr marL="0" indent="0">
+              <a:buNone/>
+            </a:pPr>
+            <a:r>
+              <a:rPr lang="en-US" sz="950" dirty="0">
+                <a:solidFill>
+                  <a:srgbClr val="E6EDF3"/>
+                </a:solidFill>
+                <a:latin typeface="Consolas" pitchFamily="34" charset="0"/>
+                <a:ea typeface="Consolas" pitchFamily="34" charset="-122"/>
+                <a:cs typeface="Consolas" pitchFamily="34" charset="-120"/>
+              </a:rPr>
+              <a:t>import json, glob</a:t>
+            </a:r>
+            <a:endParaRPr lang="en-US" sz="950" dirty="0"/>
+          </a:p>
+        </p:txBody>
+      </p:sp>
+      <p:sp>
+        <p:nvSpPr>
+          <p:cNvPr id="18" name="Text 16"/>
+          <p:cNvSpPr/>
+          <p:nvPr/>
+        </p:nvSpPr>
+        <p:spPr>
+          <a:xfrm>
+            <a:off x="5897880" y="1362456"/>
+            <a:ext cx="5852160" cy="228600"/>
+          </a:xfrm>
+          <a:prstGeom prst="rect">
+            <a:avLst/>
+          </a:prstGeom>
+          <a:noFill/>
+          <a:ln/>
+        </p:spPr>
+        <p:txBody>
+          <a:bodyPr wrap="square" lIns="0" tIns="0" rIns="0" bIns="0" rtlCol="0" anchor="ctr"/>
+          <a:lstStyle/>
+          <a:p>
+            <a:pPr marL="0" indent="0">
+              <a:buNone/>
+            </a:pPr>
+            <a:endParaRPr lang="en-US" sz="950" dirty="0"/>
+          </a:p>
+        </p:txBody>
+      </p:sp>
+      <p:sp>
+        <p:nvSpPr>
+          <p:cNvPr id="19" name="Text 17"/>
+          <p:cNvSpPr/>
+          <p:nvPr/>
+        </p:nvSpPr>
+        <p:spPr>
+          <a:xfrm>
+            <a:off x="5897880" y="1609344"/>
+            <a:ext cx="5852160" cy="228600"/>
+          </a:xfrm>
+          <a:prstGeom prst="rect">
+            <a:avLst/>
+          </a:prstGeom>
+          <a:noFill/>
+          <a:ln/>
+        </p:spPr>
+        <p:txBody>
+          <a:bodyPr wrap="square" lIns="0" tIns="0" rIns="0" bIns="0" rtlCol="0" anchor="ctr"/>
+          <a:lstStyle/>
+          <a:p>
+            <a:pPr marL="0" indent="0">
+              <a:buNone/>
+            </a:pPr>
+            <a:r>
+              <a:rPr lang="en-US" sz="950" dirty="0">
+                <a:solidFill>
+                  <a:srgbClr val="E6EDF3"/>
+                </a:solidFill>
+                <a:latin typeface="Consolas" pitchFamily="34" charset="0"/>
+                <a:ea typeface="Consolas" pitchFamily="34" charset="-122"/>
+                <a:cs typeface="Consolas" pitchFamily="34" charset="-120"/>
+              </a:rPr>
+              <a:t>run_files = sorted(glob.glob(</a:t>
+            </a:r>
+            <a:endParaRPr lang="en-US" sz="950" dirty="0"/>
+          </a:p>
+        </p:txBody>
+      </p:sp>
+      <p:sp>
+        <p:nvSpPr>
+          <p:cNvPr id="20" name="Text 18"/>
+          <p:cNvSpPr/>
+          <p:nvPr/>
+        </p:nvSpPr>
+        <p:spPr>
+          <a:xfrm>
+            <a:off x="5897880" y="1856232"/>
+            <a:ext cx="5852160" cy="228600"/>
+          </a:xfrm>
+          <a:prstGeom prst="rect">
+            <a:avLst/>
+          </a:prstGeom>
+          <a:noFill/>
+          <a:ln/>
+        </p:spPr>
+        <p:txBody>
+          <a:bodyPr wrap="square" lIns="0" tIns="0" rIns="0" bIns="0" rtlCol="0" anchor="ctr"/>
+          <a:lstStyle/>
+          <a:p>
+            <a:pPr marL="0" indent="0">
+              <a:buNone/>
+            </a:pPr>
+            <a:r>
+              <a:rPr lang="en-US" sz="950" dirty="0">
+                <a:solidFill>
+                  <a:srgbClr val="E6EDF3"/>
+                </a:solidFill>
+                <a:latin typeface="Consolas" pitchFamily="34" charset="0"/>
+                <a:ea typeface="Consolas" pitchFamily="34" charset="-122"/>
+                <a:cs typeface="Consolas" pitchFamily="34" charset="-120"/>
+              </a:rPr>
+              <a:t>    str(GARAK_RUNS / '*.report.jsonl')))</a:t>
+            </a:r>
+            <a:endParaRPr lang="en-US" sz="950" dirty="0"/>
+          </a:p>
+        </p:txBody>
+      </p:sp>
+      <p:sp>
+        <p:nvSpPr>
+          <p:cNvPr id="21" name="Text 19"/>
+          <p:cNvSpPr/>
+          <p:nvPr/>
+        </p:nvSpPr>
+        <p:spPr>
+          <a:xfrm>
+            <a:off x="5897880" y="2103120"/>
+            <a:ext cx="5852160" cy="228600"/>
+          </a:xfrm>
+          <a:prstGeom prst="rect">
+            <a:avLst/>
+          </a:prstGeom>
+          <a:noFill/>
+          <a:ln/>
+        </p:spPr>
+        <p:txBody>
+          <a:bodyPr wrap="square" lIns="0" tIns="0" rIns="0" bIns="0" rtlCol="0" anchor="ctr"/>
+          <a:lstStyle/>
+          <a:p>
+            <a:pPr marL="0" indent="0">
+              <a:buNone/>
+            </a:pPr>
+            <a:endParaRPr lang="en-US" sz="950" dirty="0"/>
+          </a:p>
+        </p:txBody>
+      </p:sp>
+      <p:sp>
+        <p:nvSpPr>
+          <p:cNvPr id="22" name="Text 20"/>
+          <p:cNvSpPr/>
+          <p:nvPr/>
+        </p:nvSpPr>
+        <p:spPr>
+          <a:xfrm>
+            <a:off x="5897880" y="2350008"/>
+            <a:ext cx="5852160" cy="228600"/>
+          </a:xfrm>
+          <a:prstGeom prst="rect">
+            <a:avLst/>
+          </a:prstGeom>
+          <a:noFill/>
+          <a:ln/>
+        </p:spPr>
+        <p:txBody>
+          <a:bodyPr wrap="square" lIns="0" tIns="0" rIns="0" bIns="0" rtlCol="0" anchor="ctr"/>
+          <a:lstStyle/>
+          <a:p>
+            <a:pPr marL="0" indent="0">
+              <a:buNone/>
+            </a:pPr>
+            <a:r>
+              <a:rPr lang="en-US" sz="950" dirty="0">
+                <a:solidFill>
+                  <a:srgbClr val="8B949E"/>
+                </a:solidFill>
+                <a:latin typeface="Consolas" pitchFamily="34" charset="0"/>
+                <a:ea typeface="Consolas" pitchFamily="34" charset="-122"/>
+                <a:cs typeface="Consolas" pitchFamily="34" charset="-120"/>
+              </a:rPr>
+              <a:t># 최신 리포트에서 eval 엔트리 추출</a:t>
+            </a:r>
+            <a:endParaRPr lang="en-US" sz="950" dirty="0"/>
+          </a:p>
+        </p:txBody>
+      </p:sp>
+      <p:sp>
+        <p:nvSpPr>
+          <p:cNvPr id="23" name="Text 21"/>
+          <p:cNvSpPr/>
+          <p:nvPr/>
+        </p:nvSpPr>
+        <p:spPr>
+          <a:xfrm>
+            <a:off x="5897880" y="2596896"/>
+            <a:ext cx="5852160" cy="228600"/>
+          </a:xfrm>
+          <a:prstGeom prst="rect">
+            <a:avLst/>
+          </a:prstGeom>
+          <a:noFill/>
+          <a:ln/>
+        </p:spPr>
+        <p:txBody>
+          <a:bodyPr wrap="square" lIns="0" tIns="0" rIns="0" bIns="0" rtlCol="0" anchor="ctr"/>
+          <a:lstStyle/>
+          <a:p>
+            <a:pPr marL="0" indent="0">
+              <a:buNone/>
+            </a:pPr>
+            <a:r>
+              <a:rPr lang="en-US" sz="950" dirty="0">
+                <a:solidFill>
+                  <a:srgbClr val="E6EDF3"/>
+                </a:solidFill>
+                <a:latin typeface="Consolas" pitchFamily="34" charset="0"/>
+                <a:ea typeface="Consolas" pitchFamily="34" charset="-122"/>
+                <a:cs typeface="Consolas" pitchFamily="34" charset="-120"/>
+              </a:rPr>
+              <a:t>target_report = max(</a:t>
+            </a:r>
+            <a:r>
+              <a:rPr lang="en-US" sz="950" dirty="0" err="1">
+                <a:solidFill>
+                  <a:srgbClr val="E6EDF3"/>
+                </a:solidFill>
+                <a:latin typeface="Consolas" pitchFamily="34" charset="0"/>
+                <a:ea typeface="Consolas" pitchFamily="34" charset="-122"/>
+                <a:cs typeface="Consolas" pitchFamily="34" charset="-120"/>
+              </a:rPr>
+              <a:t>run_files</a:t>
+            </a:r>
+            <a:r>
+              <a:rPr lang="en-US" sz="950" dirty="0">
+                <a:solidFill>
+                  <a:srgbClr val="E6EDF3"/>
+                </a:solidFill>
+                <a:latin typeface="Consolas" pitchFamily="34" charset="0"/>
+                <a:ea typeface="Consolas" pitchFamily="34" charset="-122"/>
+                <a:cs typeface="Consolas" pitchFamily="34" charset="-120"/>
+              </a:rPr>
+              <a:t>, key=</a:t>
+            </a:r>
+            <a:r>
+              <a:rPr lang="en-US" sz="950" dirty="0" err="1">
+                <a:solidFill>
+                  <a:srgbClr val="E6EDF3"/>
+                </a:solidFill>
+                <a:latin typeface="Consolas" pitchFamily="34" charset="0"/>
+                <a:ea typeface="Consolas" pitchFamily="34" charset="-122"/>
+                <a:cs typeface="Consolas" pitchFamily="34" charset="-120"/>
+              </a:rPr>
+              <a:t>os.path.getmtime</a:t>
+            </a:r>
+            <a:r>
+              <a:rPr lang="en-US" sz="950" dirty="0">
+                <a:solidFill>
+                  <a:srgbClr val="E6EDF3"/>
+                </a:solidFill>
+                <a:latin typeface="Consolas" pitchFamily="34" charset="0"/>
+                <a:ea typeface="Consolas" pitchFamily="34" charset="-122"/>
+                <a:cs typeface="Consolas" pitchFamily="34" charset="-120"/>
+              </a:rPr>
+              <a:t>)</a:t>
+            </a:r>
+            <a:endParaRPr lang="en-US" sz="950" dirty="0"/>
+          </a:p>
+        </p:txBody>
+      </p:sp>
+      <p:sp>
+        <p:nvSpPr>
+          <p:cNvPr id="24" name="Text 22"/>
+          <p:cNvSpPr/>
+          <p:nvPr/>
+        </p:nvSpPr>
+        <p:spPr>
+          <a:xfrm>
+            <a:off x="5897880" y="2843784"/>
+            <a:ext cx="5852160" cy="228600"/>
+          </a:xfrm>
+          <a:prstGeom prst="rect">
+            <a:avLst/>
+          </a:prstGeom>
+          <a:noFill/>
+          <a:ln/>
+        </p:spPr>
+        <p:txBody>
+          <a:bodyPr wrap="square" lIns="0" tIns="0" rIns="0" bIns="0" rtlCol="0" anchor="ctr"/>
+          <a:lstStyle/>
+          <a:p>
+            <a:pPr marL="0" indent="0">
+              <a:buNone/>
+            </a:pPr>
+            <a:r>
+              <a:rPr lang="en-US" sz="950" dirty="0">
+                <a:solidFill>
+                  <a:srgbClr val="E6EDF3"/>
+                </a:solidFill>
+                <a:latin typeface="Consolas" pitchFamily="34" charset="0"/>
+                <a:ea typeface="Consolas" pitchFamily="34" charset="-122"/>
+                <a:cs typeface="Consolas" pitchFamily="34" charset="-120"/>
+              </a:rPr>
+              <a:t>print(f"{'</a:t>
+            </a:r>
+            <a:r>
+              <a:rPr lang="ko-KR" altLang="en-US" sz="950" dirty="0">
+                <a:solidFill>
+                  <a:srgbClr val="E6EDF3"/>
+                </a:solidFill>
+                <a:latin typeface="Consolas" pitchFamily="34" charset="0"/>
+                <a:ea typeface="Consolas" pitchFamily="34" charset="-122"/>
+                <a:cs typeface="Consolas" pitchFamily="34" charset="-120"/>
+              </a:rPr>
+              <a:t>공격 유형</a:t>
+            </a:r>
+            <a:r>
+              <a:rPr lang="en-US" altLang="ko-KR" sz="950" dirty="0">
+                <a:solidFill>
+                  <a:srgbClr val="E6EDF3"/>
+                </a:solidFill>
+                <a:latin typeface="Consolas" pitchFamily="34" charset="0"/>
+                <a:ea typeface="Consolas" pitchFamily="34" charset="-122"/>
+                <a:cs typeface="Consolas" pitchFamily="34" charset="-120"/>
+              </a:rPr>
+              <a:t>(</a:t>
+            </a:r>
+            <a:r>
+              <a:rPr lang="en-US" sz="950" dirty="0">
+                <a:solidFill>
+                  <a:srgbClr val="E6EDF3"/>
+                </a:solidFill>
+                <a:latin typeface="Consolas" pitchFamily="34" charset="0"/>
+                <a:ea typeface="Consolas" pitchFamily="34" charset="-122"/>
+                <a:cs typeface="Consolas" pitchFamily="34" charset="-120"/>
+              </a:rPr>
+              <a:t>Probe)':&lt;30} | {'</a:t>
+            </a:r>
+            <a:r>
+              <a:rPr lang="ko-KR" altLang="en-US" sz="950" dirty="0">
+                <a:solidFill>
+                  <a:srgbClr val="E6EDF3"/>
+                </a:solidFill>
+                <a:latin typeface="Consolas" pitchFamily="34" charset="0"/>
+                <a:ea typeface="Consolas" pitchFamily="34" charset="-122"/>
+                <a:cs typeface="Consolas" pitchFamily="34" charset="-120"/>
+              </a:rPr>
+              <a:t>검사기</a:t>
+            </a:r>
+            <a:r>
+              <a:rPr lang="en-US" altLang="ko-KR" sz="950" dirty="0">
+                <a:solidFill>
+                  <a:srgbClr val="E6EDF3"/>
+                </a:solidFill>
+                <a:latin typeface="Consolas" pitchFamily="34" charset="0"/>
+                <a:ea typeface="Consolas" pitchFamily="34" charset="-122"/>
+                <a:cs typeface="Consolas" pitchFamily="34" charset="-120"/>
+              </a:rPr>
+              <a:t>(</a:t>
+            </a:r>
+            <a:r>
+              <a:rPr lang="en-US" sz="950" dirty="0">
+                <a:solidFill>
+                  <a:srgbClr val="E6EDF3"/>
+                </a:solidFill>
+                <a:latin typeface="Consolas" pitchFamily="34" charset="0"/>
+                <a:ea typeface="Consolas" pitchFamily="34" charset="-122"/>
+                <a:cs typeface="Consolas" pitchFamily="34" charset="-120"/>
+              </a:rPr>
+              <a:t>Detector)':&lt;40} | {'</a:t>
+            </a:r>
+            <a:r>
+              <a:rPr lang="ko-KR" altLang="en-US" sz="950" dirty="0">
+                <a:solidFill>
+                  <a:srgbClr val="E6EDF3"/>
+                </a:solidFill>
+                <a:latin typeface="Consolas" pitchFamily="34" charset="0"/>
+                <a:ea typeface="Consolas" pitchFamily="34" charset="-122"/>
+                <a:cs typeface="Consolas" pitchFamily="34" charset="-120"/>
+              </a:rPr>
+              <a:t>결과</a:t>
+            </a:r>
+            <a:r>
+              <a:rPr lang="en-US" altLang="ko-KR" sz="950" dirty="0">
+                <a:solidFill>
+                  <a:srgbClr val="E6EDF3"/>
+                </a:solidFill>
+                <a:latin typeface="Consolas" pitchFamily="34" charset="0"/>
+                <a:ea typeface="Consolas" pitchFamily="34" charset="-122"/>
+                <a:cs typeface="Consolas" pitchFamily="34" charset="-120"/>
+              </a:rPr>
+              <a:t>'}")</a:t>
+            </a:r>
+          </a:p>
+        </p:txBody>
+      </p:sp>
+      <p:sp>
+        <p:nvSpPr>
+          <p:cNvPr id="29" name="Text 27"/>
+          <p:cNvSpPr/>
+          <p:nvPr/>
+        </p:nvSpPr>
+        <p:spPr>
+          <a:xfrm>
+            <a:off x="5897880" y="3306682"/>
+            <a:ext cx="5852160" cy="228600"/>
+          </a:xfrm>
+          <a:prstGeom prst="rect">
+            <a:avLst/>
+          </a:prstGeom>
+          <a:noFill/>
+          <a:ln/>
+        </p:spPr>
+        <p:txBody>
+          <a:bodyPr wrap="square" lIns="0" tIns="0" rIns="0" bIns="0" rtlCol="0" anchor="ctr"/>
+          <a:lstStyle/>
+          <a:p>
+            <a:pPr marL="0" indent="0">
+              <a:buNone/>
+            </a:pPr>
+            <a:r>
+              <a:rPr lang="en-US" sz="950" dirty="0">
+                <a:solidFill>
+                  <a:srgbClr val="8B949E"/>
+                </a:solidFill>
+                <a:latin typeface="Consolas" pitchFamily="34" charset="0"/>
+                <a:ea typeface="Consolas" pitchFamily="34" charset="-122"/>
+                <a:cs typeface="Consolas" pitchFamily="34" charset="-120"/>
+              </a:rPr>
+              <a:t># </a:t>
+            </a:r>
+            <a:r>
+              <a:rPr lang="ko-KR" altLang="en-US" sz="950" dirty="0">
+                <a:solidFill>
+                  <a:srgbClr val="8B949E"/>
+                </a:solidFill>
+                <a:latin typeface="Consolas" pitchFamily="34" charset="0"/>
+                <a:ea typeface="Consolas" pitchFamily="34" charset="-122"/>
+                <a:cs typeface="Consolas" pitchFamily="34" charset="-120"/>
+              </a:rPr>
+              <a:t>선택된 단일파일의 </a:t>
+            </a:r>
+            <a:r>
+              <a:rPr lang="en-US" altLang="ko-KR" sz="950" dirty="0">
+                <a:solidFill>
+                  <a:srgbClr val="8B949E"/>
+                </a:solidFill>
+                <a:latin typeface="Consolas" pitchFamily="34" charset="0"/>
+                <a:ea typeface="Consolas" pitchFamily="34" charset="-122"/>
+                <a:cs typeface="Consolas" pitchFamily="34" charset="-120"/>
+              </a:rPr>
+              <a:t>‘eval’ </a:t>
+            </a:r>
+            <a:r>
+              <a:rPr lang="ko-KR" altLang="en-US" sz="950" dirty="0">
+                <a:solidFill>
+                  <a:srgbClr val="8B949E"/>
+                </a:solidFill>
+                <a:latin typeface="Consolas" pitchFamily="34" charset="0"/>
+                <a:ea typeface="Consolas" pitchFamily="34" charset="-122"/>
+                <a:cs typeface="Consolas" pitchFamily="34" charset="-120"/>
+              </a:rPr>
+              <a:t>엔트리만 </a:t>
+            </a:r>
+            <a:r>
+              <a:rPr lang="ko-KR" altLang="en-US" sz="950" dirty="0" err="1">
+                <a:solidFill>
+                  <a:srgbClr val="8B949E"/>
+                </a:solidFill>
+                <a:latin typeface="Consolas" pitchFamily="34" charset="0"/>
+                <a:ea typeface="Consolas" pitchFamily="34" charset="-122"/>
+                <a:cs typeface="Consolas" pitchFamily="34" charset="-120"/>
+              </a:rPr>
+              <a:t>파싱하여</a:t>
+            </a:r>
+            <a:r>
+              <a:rPr lang="ko-KR" altLang="en-US" sz="950" dirty="0">
+                <a:solidFill>
+                  <a:srgbClr val="8B949E"/>
+                </a:solidFill>
+                <a:latin typeface="Consolas" pitchFamily="34" charset="0"/>
+                <a:ea typeface="Consolas" pitchFamily="34" charset="-122"/>
+                <a:cs typeface="Consolas" pitchFamily="34" charset="-120"/>
+              </a:rPr>
+              <a:t> 출력</a:t>
+            </a:r>
+            <a:endParaRPr lang="en-US" sz="950" dirty="0"/>
+          </a:p>
+        </p:txBody>
+      </p:sp>
+      <p:sp>
+        <p:nvSpPr>
+          <p:cNvPr id="30" name="Text 28"/>
+          <p:cNvSpPr/>
+          <p:nvPr/>
+        </p:nvSpPr>
+        <p:spPr>
+          <a:xfrm>
+            <a:off x="5897880" y="3553569"/>
+            <a:ext cx="5852160" cy="1879821"/>
+          </a:xfrm>
+          <a:prstGeom prst="rect">
+            <a:avLst/>
+          </a:prstGeom>
+          <a:noFill/>
+          <a:ln/>
+        </p:spPr>
+        <p:txBody>
+          <a:bodyPr wrap="square" lIns="0" tIns="0" rIns="0" bIns="0" rtlCol="0" anchor="t"/>
+          <a:lstStyle/>
+          <a:p>
+            <a:pPr marL="0" indent="0">
+              <a:buNone/>
+            </a:pPr>
+            <a:r>
+              <a:rPr lang="es-419" altLang="ko-KR" sz="950" dirty="0">
+                <a:solidFill>
+                  <a:srgbClr val="E6EDF3"/>
+                </a:solidFill>
+                <a:latin typeface="Consolas" pitchFamily="34" charset="0"/>
+                <a:ea typeface="Consolas" pitchFamily="34" charset="-122"/>
+                <a:cs typeface="Consolas" pitchFamily="34" charset="-120"/>
+              </a:rPr>
+              <a:t>with open(target_report, 'r') as f:</a:t>
+            </a:r>
+          </a:p>
+          <a:p>
+            <a:pPr marL="0" indent="0">
+              <a:buNone/>
+            </a:pPr>
+            <a:r>
+              <a:rPr lang="ko-KR" altLang="en-US" sz="950" dirty="0">
+                <a:solidFill>
+                  <a:srgbClr val="E6EDF3"/>
+                </a:solidFill>
+                <a:latin typeface="Consolas" pitchFamily="34" charset="0"/>
+                <a:ea typeface="Consolas" pitchFamily="34" charset="-122"/>
+                <a:cs typeface="Consolas" pitchFamily="34" charset="-120"/>
+              </a:rPr>
+              <a:t>    </a:t>
+            </a:r>
+            <a:r>
+              <a:rPr lang="es-419" altLang="ko-KR" sz="950" dirty="0">
+                <a:solidFill>
+                  <a:srgbClr val="E6EDF3"/>
+                </a:solidFill>
+                <a:latin typeface="Consolas" pitchFamily="34" charset="0"/>
+                <a:ea typeface="Consolas" pitchFamily="34" charset="-122"/>
+                <a:cs typeface="Consolas" pitchFamily="34" charset="-120"/>
+              </a:rPr>
+              <a:t>for line in f:</a:t>
+            </a:r>
+          </a:p>
+          <a:p>
+            <a:pPr marL="0" indent="0">
+              <a:buNone/>
+            </a:pPr>
+            <a:r>
+              <a:rPr lang="ko-KR" altLang="en-US" sz="950" dirty="0">
+                <a:solidFill>
+                  <a:srgbClr val="E6EDF3"/>
+                </a:solidFill>
+                <a:latin typeface="Consolas" pitchFamily="34" charset="0"/>
+                <a:ea typeface="Consolas" pitchFamily="34" charset="-122"/>
+                <a:cs typeface="Consolas" pitchFamily="34" charset="-120"/>
+              </a:rPr>
+              <a:t>        </a:t>
+            </a:r>
+            <a:r>
+              <a:rPr lang="es-419" altLang="ko-KR" sz="950" dirty="0">
+                <a:solidFill>
+                  <a:srgbClr val="E6EDF3"/>
+                </a:solidFill>
+                <a:latin typeface="Consolas" pitchFamily="34" charset="0"/>
+                <a:ea typeface="Consolas" pitchFamily="34" charset="-122"/>
+                <a:cs typeface="Consolas" pitchFamily="34" charset="-120"/>
+              </a:rPr>
+              <a:t>data = json.loads(line)</a:t>
+            </a:r>
+          </a:p>
+          <a:p>
+            <a:pPr marL="0" indent="0">
+              <a:buNone/>
+            </a:pPr>
+            <a:r>
+              <a:rPr lang="ko-KR" altLang="en-US" sz="950" dirty="0">
+                <a:solidFill>
+                  <a:srgbClr val="E6EDF3"/>
+                </a:solidFill>
+                <a:latin typeface="Consolas" pitchFamily="34" charset="0"/>
+                <a:ea typeface="Consolas" pitchFamily="34" charset="-122"/>
+                <a:cs typeface="Consolas" pitchFamily="34" charset="-120"/>
+              </a:rPr>
+              <a:t>        </a:t>
+            </a:r>
+            <a:r>
+              <a:rPr lang="es-419" altLang="ko-KR" sz="950" dirty="0">
+                <a:solidFill>
+                  <a:srgbClr val="E6EDF3"/>
+                </a:solidFill>
+                <a:latin typeface="Consolas" pitchFamily="34" charset="0"/>
+                <a:ea typeface="Consolas" pitchFamily="34" charset="-122"/>
+                <a:cs typeface="Consolas" pitchFamily="34" charset="-120"/>
+              </a:rPr>
+              <a:t>if</a:t>
+            </a:r>
+            <a:r>
+              <a:rPr lang="en-US" altLang="ko-KR" sz="950" dirty="0">
+                <a:solidFill>
+                  <a:srgbClr val="E6EDF3"/>
+                </a:solidFill>
+                <a:latin typeface="Consolas" pitchFamily="34" charset="0"/>
+                <a:ea typeface="Consolas" pitchFamily="34" charset="-122"/>
+                <a:cs typeface="Consolas" pitchFamily="34" charset="-120"/>
+              </a:rPr>
+              <a:t> </a:t>
+            </a:r>
+            <a:r>
+              <a:rPr lang="es-419" altLang="ko-KR" sz="950" dirty="0">
+                <a:solidFill>
+                  <a:srgbClr val="E6EDF3"/>
+                </a:solidFill>
+                <a:latin typeface="Consolas" pitchFamily="34" charset="0"/>
+                <a:ea typeface="Consolas" pitchFamily="34" charset="-122"/>
+                <a:cs typeface="Consolas" pitchFamily="34" charset="-120"/>
+              </a:rPr>
+              <a:t>data.get('entry_type') == 'eval＇:</a:t>
+            </a:r>
+          </a:p>
+          <a:p>
+            <a:pPr marL="0" indent="0">
+              <a:buNone/>
+            </a:pPr>
+            <a:r>
+              <a:rPr lang="ko-KR" altLang="en-US" sz="950" dirty="0">
+                <a:solidFill>
+                  <a:srgbClr val="E6EDF3"/>
+                </a:solidFill>
+                <a:latin typeface="Consolas" pitchFamily="34" charset="0"/>
+                <a:ea typeface="Consolas" pitchFamily="34" charset="-122"/>
+                <a:cs typeface="Consolas" pitchFamily="34" charset="-120"/>
+              </a:rPr>
+              <a:t>            </a:t>
+            </a:r>
+            <a:r>
+              <a:rPr lang="es-419" altLang="ko-KR" sz="950" dirty="0">
+                <a:solidFill>
+                  <a:srgbClr val="E6EDF3"/>
+                </a:solidFill>
+                <a:latin typeface="Consolas" pitchFamily="34" charset="0"/>
+                <a:ea typeface="Consolas" pitchFamily="34" charset="-122"/>
+                <a:cs typeface="Consolas" pitchFamily="34" charset="-120"/>
+              </a:rPr>
+              <a:t>status</a:t>
+            </a:r>
+            <a:r>
+              <a:rPr lang="en-US" altLang="ko-KR" sz="950" dirty="0">
+                <a:solidFill>
+                  <a:srgbClr val="E6EDF3"/>
+                </a:solidFill>
+                <a:latin typeface="Consolas" pitchFamily="34" charset="0"/>
+                <a:ea typeface="Consolas" pitchFamily="34" charset="-122"/>
+                <a:cs typeface="Consolas" pitchFamily="34" charset="-120"/>
+              </a:rPr>
+              <a:t> </a:t>
+            </a:r>
+            <a:r>
+              <a:rPr lang="es-419" altLang="ko-KR" sz="950" dirty="0">
+                <a:solidFill>
+                  <a:srgbClr val="E6EDF3"/>
+                </a:solidFill>
+                <a:latin typeface="Consolas" pitchFamily="34" charset="0"/>
+                <a:ea typeface="Consolas" pitchFamily="34" charset="-122"/>
+                <a:cs typeface="Consolas" pitchFamily="34" charset="-120"/>
+              </a:rPr>
+              <a:t>= 'FAIL' if data['fails'] &gt; 0 else 'PASS＇</a:t>
+            </a:r>
+          </a:p>
+          <a:p>
+            <a:pPr marL="0" indent="0">
+              <a:buNone/>
+            </a:pPr>
+            <a:r>
+              <a:rPr lang="ko-KR" altLang="en-US" sz="950" dirty="0">
+                <a:solidFill>
+                  <a:srgbClr val="E6EDF3"/>
+                </a:solidFill>
+                <a:latin typeface="Consolas" pitchFamily="34" charset="0"/>
+                <a:ea typeface="Consolas" pitchFamily="34" charset="-122"/>
+                <a:cs typeface="Consolas" pitchFamily="34" charset="-120"/>
+              </a:rPr>
+              <a:t>            </a:t>
+            </a:r>
+            <a:r>
+              <a:rPr lang="es-419" altLang="ko-KR" sz="950" dirty="0">
+                <a:solidFill>
+                  <a:srgbClr val="E6EDF3"/>
+                </a:solidFill>
+                <a:latin typeface="Consolas" pitchFamily="34" charset="0"/>
+                <a:ea typeface="Consolas" pitchFamily="34" charset="-122"/>
+                <a:cs typeface="Consolas" pitchFamily="34" charset="-120"/>
+              </a:rPr>
+              <a:t>probe = data['probe＇]</a:t>
+            </a:r>
+            <a:r>
+              <a:rPr lang="ko-KR" altLang="en-US" sz="950" dirty="0">
+                <a:solidFill>
+                  <a:srgbClr val="E6EDF3"/>
+                </a:solidFill>
+                <a:latin typeface="Consolas" pitchFamily="34" charset="0"/>
+                <a:ea typeface="Consolas" pitchFamily="34" charset="-122"/>
+                <a:cs typeface="Consolas" pitchFamily="34" charset="-120"/>
+              </a:rPr>
+              <a:t>   </a:t>
+            </a:r>
+            <a:endParaRPr lang="es-419" altLang="ko-KR" sz="950" dirty="0">
+              <a:solidFill>
+                <a:srgbClr val="E6EDF3"/>
+              </a:solidFill>
+              <a:latin typeface="Consolas" pitchFamily="34" charset="0"/>
+              <a:ea typeface="Consolas" pitchFamily="34" charset="-122"/>
+              <a:cs typeface="Consolas" pitchFamily="34" charset="-120"/>
+            </a:endParaRPr>
+          </a:p>
+          <a:p>
+            <a:pPr marL="0" indent="0">
+              <a:buNone/>
+            </a:pPr>
+            <a:r>
+              <a:rPr lang="ko-KR" altLang="en-US" sz="950" dirty="0">
+                <a:solidFill>
+                  <a:srgbClr val="E6EDF3"/>
+                </a:solidFill>
+                <a:latin typeface="Consolas" pitchFamily="34" charset="0"/>
+                <a:ea typeface="Consolas" pitchFamily="34" charset="-122"/>
+                <a:cs typeface="Consolas" pitchFamily="34" charset="-120"/>
+              </a:rPr>
+              <a:t>           </a:t>
+            </a:r>
+            <a:r>
+              <a:rPr lang="en-US" altLang="ko-KR" sz="950" dirty="0">
+                <a:solidFill>
+                  <a:srgbClr val="E6EDF3"/>
+                </a:solidFill>
+                <a:latin typeface="Consolas" pitchFamily="34" charset="0"/>
+                <a:ea typeface="Consolas" pitchFamily="34" charset="-122"/>
+                <a:cs typeface="Consolas" pitchFamily="34" charset="-120"/>
+              </a:rPr>
+              <a:t> d</a:t>
+            </a:r>
+            <a:r>
+              <a:rPr lang="es-419" altLang="ko-KR" sz="950" dirty="0">
+                <a:solidFill>
+                  <a:srgbClr val="E6EDF3"/>
+                </a:solidFill>
+                <a:latin typeface="Consolas" pitchFamily="34" charset="0"/>
+                <a:ea typeface="Consolas" pitchFamily="34" charset="-122"/>
+                <a:cs typeface="Consolas" pitchFamily="34" charset="-120"/>
+              </a:rPr>
+              <a:t>etector = data['detector’]</a:t>
+            </a:r>
+          </a:p>
+          <a:p>
+            <a:pPr marL="0" indent="0">
+              <a:buNone/>
+            </a:pPr>
+            <a:r>
+              <a:rPr lang="es-419" altLang="ko-KR" sz="950" dirty="0">
+                <a:solidFill>
+                  <a:srgbClr val="E6EDF3"/>
+                </a:solidFill>
+                <a:latin typeface="Consolas" pitchFamily="34" charset="0"/>
+                <a:ea typeface="Consolas" pitchFamily="34" charset="-122"/>
+                <a:cs typeface="Consolas" pitchFamily="34" charset="-120"/>
+              </a:rPr>
+              <a:t>            print(f"{probe:&lt;30} | {detector:&lt;40} | {status}")</a:t>
+            </a:r>
+          </a:p>
+        </p:txBody>
+      </p:sp>
+      <p:sp>
+        <p:nvSpPr>
+          <p:cNvPr id="39" name="Text 37"/>
+          <p:cNvSpPr/>
+          <p:nvPr/>
+        </p:nvSpPr>
+        <p:spPr>
+          <a:xfrm>
+            <a:off x="11064240" y="6510528"/>
+            <a:ext cx="914400" cy="274320"/>
+          </a:xfrm>
+          <a:prstGeom prst="rect">
+            <a:avLst/>
+          </a:prstGeom>
+          <a:noFill/>
+          <a:ln/>
+        </p:spPr>
+        <p:txBody>
+          <a:bodyPr wrap="square" lIns="0" tIns="0" rIns="0" bIns="0" rtlCol="0" anchor="ctr"/>
+          <a:lstStyle/>
+          <a:p>
+            <a:pPr marL="0" indent="0" algn="r">
+              <a:buNone/>
+            </a:pPr>
+            <a:r>
+              <a:rPr lang="en-US" sz="900" dirty="0">
+                <a:solidFill>
+                  <a:srgbClr val="94A3B8"/>
+                </a:solidFill>
+                <a:latin typeface="Arial" pitchFamily="34" charset="0"/>
+                <a:ea typeface="Arial" pitchFamily="34" charset="-122"/>
+                <a:cs typeface="Arial" pitchFamily="34" charset="-120"/>
+              </a:rPr>
+              <a:t>9 / 19</a:t>
+            </a:r>
+            <a:endParaRPr lang="en-US" sz="900" dirty="0"/>
+          </a:p>
+        </p:txBody>
+      </p:sp>
+    </p:spTree>
+  </p:cSld>
+  <p:clrMapOvr>
+    <a:masterClrMapping/>
+  </p:clrMapOvr>
+</p:sld>
+</file>
+
+<file path=ppt/slides/slide11.xml><?xml version="1.0" encoding="utf-8"?>
 <p:sld xmlns:a="http://schemas.openxmlformats.org/drawingml/2006/main" xmlns:r="http://schemas.openxmlformats.org/officeDocument/2006/relationships" xmlns:p="http://schemas.openxmlformats.org/presentationml/2006/main">
   <p:cSld name="Slide 10">
     <p:bg>
@@ -9952,7 +11327,7 @@
 </p:sld>
 </file>
 
-<file path=ppt/slides/slide11.xml><?xml version="1.0" encoding="utf-8"?>
+<file path=ppt/slides/slide12.xml><?xml version="1.0" encoding="utf-8"?>
 <p:sld xmlns:a="http://schemas.openxmlformats.org/drawingml/2006/main" xmlns:r="http://schemas.openxmlformats.org/officeDocument/2006/relationships" xmlns:p="http://schemas.openxmlformats.org/presentationml/2006/main">
   <p:cSld name="Slide 11">
     <p:bg>
@@ -10823,7 +12198,7 @@
 </p:sld>
 </file>
 
-<file path=ppt/slides/slide12.xml><?xml version="1.0" encoding="utf-8"?>
+<file path=ppt/slides/slide13.xml><?xml version="1.0" encoding="utf-8"?>
 <p:sld xmlns:a="http://schemas.openxmlformats.org/drawingml/2006/main" xmlns:r="http://schemas.openxmlformats.org/officeDocument/2006/relationships" xmlns:p="http://schemas.openxmlformats.org/presentationml/2006/main">
   <p:cSld name="Slide 12">
     <p:bg>
@@ -12368,7 +13743,7 @@
 </p:sld>
 </file>
 
-<file path=ppt/slides/slide13.xml><?xml version="1.0" encoding="utf-8"?>
+<file path=ppt/slides/slide14.xml><?xml version="1.0" encoding="utf-8"?>
 <p:sld xmlns:a="http://schemas.openxmlformats.org/drawingml/2006/main" xmlns:r="http://schemas.openxmlformats.org/officeDocument/2006/relationships" xmlns:p="http://schemas.openxmlformats.org/presentationml/2006/main">
   <p:cSld name="Slide 13">
     <p:bg>
@@ -13952,7 +15327,590 @@
 </p:sld>
 </file>
 
-<file path=ppt/slides/slide14.xml><?xml version="1.0" encoding="utf-8"?>
+<file path=ppt/slides/slide15.xml><?xml version="1.0" encoding="utf-8"?>
+<p:sld xmlns:a="http://schemas.openxmlformats.org/drawingml/2006/main" xmlns:r="http://schemas.openxmlformats.org/officeDocument/2006/relationships" xmlns:p="http://schemas.openxmlformats.org/presentationml/2006/main">
+  <p:cSld>
+    <p:bg>
+      <p:bgPr>
+        <a:solidFill>
+          <a:srgbClr val="111848"/>
+        </a:solidFill>
+        <a:effectLst/>
+      </p:bgPr>
+    </p:bg>
+    <p:spTree>
+      <p:nvGrpSpPr>
+        <p:cNvPr id="1" name=""/>
+        <p:cNvGrpSpPr/>
+        <p:nvPr/>
+      </p:nvGrpSpPr>
+      <p:grpSpPr>
+        <a:xfrm>
+          <a:off x="0" y="0"/>
+          <a:ext cx="0" cy="0"/>
+          <a:chOff x="0" y="0"/>
+          <a:chExt cx="0" cy="0"/>
+        </a:xfrm>
+      </p:grpSpPr>
+      <p:sp>
+        <p:nvSpPr>
+          <p:cNvPr id="2" name="Rectangle 1"/>
+          <p:cNvSpPr/>
+          <p:nvPr/>
+        </p:nvSpPr>
+        <p:spPr>
+          <a:xfrm>
+            <a:off x="0" y="0"/>
+            <a:ext cx="12192000" cy="73152"/>
+          </a:xfrm>
+          <a:prstGeom prst="rect">
+            <a:avLst/>
+          </a:prstGeom>
+          <a:solidFill>
+            <a:srgbClr val="EF4444"/>
+          </a:solidFill>
+          <a:ln>
+            <a:noFill/>
+          </a:ln>
+        </p:spPr>
+        <p:style>
+          <a:lnRef idx="1">
+            <a:schemeClr val="accent1"/>
+          </a:lnRef>
+          <a:fillRef idx="3">
+            <a:schemeClr val="accent1"/>
+          </a:fillRef>
+          <a:effectRef idx="2">
+            <a:schemeClr val="accent1"/>
+          </a:effectRef>
+          <a:fontRef idx="minor">
+            <a:schemeClr val="lt1"/>
+          </a:fontRef>
+        </p:style>
+        <p:txBody>
+          <a:bodyPr wrap="square" lIns="60960" tIns="30480" rIns="60960" bIns="30480" rtlCol="0" anchor="ctr">
+            <a:noAutofit/>
+          </a:bodyPr>
+          <a:lstStyle/>
+          <a:p>
+            <a:pPr algn="ctr">
+              <a:defRPr/>
+            </a:pPr>
+            <a:endParaRPr/>
+          </a:p>
+        </p:txBody>
+      </p:sp>
+      <p:sp>
+        <p:nvSpPr>
+          <p:cNvPr id="3" name="TextBox 2"/>
+          <p:cNvSpPr txBox="1"/>
+          <p:nvPr/>
+        </p:nvSpPr>
+        <p:spPr>
+          <a:xfrm>
+            <a:off x="0" y="182880"/>
+            <a:ext cx="12192000" cy="548640"/>
+          </a:xfrm>
+          <a:prstGeom prst="rect">
+            <a:avLst/>
+          </a:prstGeom>
+          <a:noFill/>
+          <a:ln/>
+        </p:spPr>
+        <p:txBody>
+          <a:bodyPr wrap="square" lIns="60960" tIns="30480" rIns="60960" bIns="30480">
+            <a:noAutofit/>
+          </a:bodyPr>
+          <a:lstStyle/>
+          <a:p>
+            <a:pPr algn="ctr">
+              <a:defRPr/>
+            </a:pPr>
+            <a:r>
+              <a:rPr sz="2266" b="1">
+                <a:solidFill>
+                  <a:srgbClr val="FFFFFF"/>
+                </a:solidFill>
+                <a:latin typeface="Calibri"/>
+              </a:rPr>
+              <a:t>⚔  자유 공격·방어 시간  —  슬롯 5</a:t>
+            </a:r>
+          </a:p>
+        </p:txBody>
+      </p:sp>
+      <p:sp>
+        <p:nvSpPr>
+          <p:cNvPr id="4" name="TextBox 3"/>
+          <p:cNvSpPr txBox="1"/>
+          <p:nvPr/>
+        </p:nvSpPr>
+        <p:spPr>
+          <a:xfrm>
+            <a:off x="0" y="731520"/>
+            <a:ext cx="12192000" cy="365760"/>
+          </a:xfrm>
+          <a:prstGeom prst="rect">
+            <a:avLst/>
+          </a:prstGeom>
+          <a:noFill/>
+          <a:ln/>
+        </p:spPr>
+        <p:txBody>
+          <a:bodyPr wrap="square" lIns="60960" tIns="30480" rIns="60960" bIns="30480">
+            <a:noAutofit/>
+          </a:bodyPr>
+          <a:lstStyle/>
+          <a:p>
+            <a:pPr algn="ctr">
+              <a:defRPr/>
+            </a:pPr>
+            <a:r>
+              <a:rPr sz="1466" b="0">
+                <a:solidFill>
+                  <a:srgbClr val="06B6D4"/>
+                </a:solidFill>
+                <a:latin typeface="Calibri"/>
+              </a:rPr>
+              <a:t>Garak 커스텀 프로브 확장 · LLM Guard 튜닝 — 나만의 레드팀 도구 만들기</a:t>
+            </a:r>
+          </a:p>
+        </p:txBody>
+      </p:sp>
+      <p:sp>
+        <p:nvSpPr>
+          <p:cNvPr id="7" name="TextBox 6"/>
+          <p:cNvSpPr txBox="1"/>
+          <p:nvPr/>
+        </p:nvSpPr>
+        <p:spPr>
+          <a:xfrm>
+            <a:off x="487680" y="1341120"/>
+            <a:ext cx="1828800" cy="365760"/>
+          </a:xfrm>
+          <a:prstGeom prst="rect">
+            <a:avLst/>
+          </a:prstGeom>
+          <a:noFill/>
+          <a:ln/>
+        </p:spPr>
+        <p:txBody>
+          <a:bodyPr wrap="square" lIns="60960" tIns="30480" rIns="60960" bIns="30480">
+            <a:noAutofit/>
+          </a:bodyPr>
+          <a:lstStyle/>
+          <a:p>
+            <a:pPr algn="l">
+              <a:defRPr/>
+            </a:pPr>
+            <a:r>
+              <a:rPr sz="1466" b="1">
+                <a:solidFill>
+                  <a:srgbClr val="F59E0B"/>
+                </a:solidFill>
+                <a:latin typeface="Calibri"/>
+              </a:rPr>
+              <a:t>🎯 미션</a:t>
+            </a:r>
+          </a:p>
+        </p:txBody>
+      </p:sp>
+      <p:sp>
+        <p:nvSpPr>
+          <p:cNvPr id="8" name="Rectangle 7"/>
+          <p:cNvSpPr/>
+          <p:nvPr/>
+        </p:nvSpPr>
+        <p:spPr>
+          <a:xfrm>
+            <a:off x="487680" y="1828800"/>
+            <a:ext cx="11216640" cy="701040"/>
+          </a:xfrm>
+          <a:prstGeom prst="rect">
+            <a:avLst/>
+          </a:prstGeom>
+          <a:solidFill>
+            <a:srgbClr val="1C235A"/>
+          </a:solidFill>
+          <a:ln>
+            <a:noFill/>
+          </a:ln>
+        </p:spPr>
+        <p:style>
+          <a:lnRef idx="1">
+            <a:schemeClr val="accent1"/>
+          </a:lnRef>
+          <a:fillRef idx="3">
+            <a:schemeClr val="accent1"/>
+          </a:fillRef>
+          <a:effectRef idx="2">
+            <a:schemeClr val="accent1"/>
+          </a:effectRef>
+          <a:fontRef idx="minor">
+            <a:schemeClr val="lt1"/>
+          </a:fontRef>
+        </p:style>
+        <p:txBody>
+          <a:bodyPr wrap="square" lIns="60960" tIns="30480" rIns="60960" bIns="30480" rtlCol="0" anchor="ctr">
+            <a:noAutofit/>
+          </a:bodyPr>
+          <a:lstStyle/>
+          <a:p>
+            <a:pPr algn="ctr">
+              <a:defRPr/>
+            </a:pPr>
+            <a:endParaRPr/>
+          </a:p>
+        </p:txBody>
+      </p:sp>
+      <p:sp>
+        <p:nvSpPr>
+          <p:cNvPr id="9" name="Rectangle 8"/>
+          <p:cNvSpPr/>
+          <p:nvPr/>
+        </p:nvSpPr>
+        <p:spPr>
+          <a:xfrm>
+            <a:off x="579120" y="1981200"/>
+            <a:ext cx="396240" cy="396240"/>
+          </a:xfrm>
+          <a:prstGeom prst="rect">
+            <a:avLst/>
+          </a:prstGeom>
+          <a:solidFill>
+            <a:srgbClr val="06B6D4"/>
+          </a:solidFill>
+          <a:ln>
+            <a:noFill/>
+          </a:ln>
+        </p:spPr>
+        <p:style>
+          <a:lnRef idx="1">
+            <a:schemeClr val="accent1"/>
+          </a:lnRef>
+          <a:fillRef idx="3">
+            <a:schemeClr val="accent1"/>
+          </a:fillRef>
+          <a:effectRef idx="2">
+            <a:schemeClr val="accent1"/>
+          </a:effectRef>
+          <a:fontRef idx="minor">
+            <a:schemeClr val="lt1"/>
+          </a:fontRef>
+        </p:style>
+        <p:txBody>
+          <a:bodyPr wrap="square" lIns="60960" tIns="30480" rIns="60960" bIns="30480" rtlCol="0" anchor="ctr">
+            <a:noAutofit/>
+          </a:bodyPr>
+          <a:lstStyle/>
+          <a:p>
+            <a:pPr algn="ctr">
+              <a:defRPr/>
+            </a:pPr>
+            <a:endParaRPr/>
+          </a:p>
+        </p:txBody>
+      </p:sp>
+      <p:sp>
+        <p:nvSpPr>
+          <p:cNvPr id="10" name="TextBox 9"/>
+          <p:cNvSpPr txBox="1"/>
+          <p:nvPr/>
+        </p:nvSpPr>
+        <p:spPr>
+          <a:xfrm>
+            <a:off x="579120" y="1981200"/>
+            <a:ext cx="396240" cy="396240"/>
+          </a:xfrm>
+          <a:prstGeom prst="rect">
+            <a:avLst/>
+          </a:prstGeom>
+          <a:noFill/>
+          <a:ln/>
+        </p:spPr>
+        <p:txBody>
+          <a:bodyPr wrap="square" lIns="60960" tIns="30480" rIns="60960" bIns="30480">
+            <a:noAutofit/>
+          </a:bodyPr>
+          <a:lstStyle/>
+          <a:p>
+            <a:pPr algn="ctr">
+              <a:defRPr/>
+            </a:pPr>
+            <a:r>
+              <a:rPr sz="1333" b="1">
+                <a:solidFill>
+                  <a:srgbClr val="111848"/>
+                </a:solidFill>
+                <a:latin typeface="Calibri"/>
+              </a:rPr>
+              <a:t>1</a:t>
+            </a:r>
+          </a:p>
+        </p:txBody>
+      </p:sp>
+      <p:sp>
+        <p:nvSpPr>
+          <p:cNvPr id="11" name="TextBox 10"/>
+          <p:cNvSpPr txBox="1"/>
+          <p:nvPr/>
+        </p:nvSpPr>
+        <p:spPr>
+          <a:xfrm>
+            <a:off x="1097280" y="1889760"/>
+            <a:ext cx="10363200" cy="579120"/>
+          </a:xfrm>
+          <a:prstGeom prst="rect">
+            <a:avLst/>
+          </a:prstGeom>
+          <a:noFill/>
+          <a:ln/>
+        </p:spPr>
+        <p:txBody>
+          <a:bodyPr wrap="square" lIns="60960" tIns="30480" rIns="60960" bIns="30480">
+            <a:noAutofit/>
+          </a:bodyPr>
+          <a:lstStyle/>
+          <a:p>
+            <a:pPr algn="l">
+              <a:defRPr/>
+            </a:pPr>
+            <a:r>
+              <a:rPr sz="1333" b="0">
+                <a:solidFill>
+                  <a:srgbClr val="FFFFFF"/>
+                </a:solidFill>
+                <a:latin typeface="Calibri"/>
+              </a:rPr>
+              <a:t>CUSTOM_PAYLOADS에 자기 기관 업무 시나리오 맞춤 페이로드 3개를 추가하세요.</a:t>
+            </a:r>
+          </a:p>
+        </p:txBody>
+      </p:sp>
+      <p:sp>
+        <p:nvSpPr>
+          <p:cNvPr id="16" name="Rectangle 15"/>
+          <p:cNvSpPr/>
+          <p:nvPr/>
+        </p:nvSpPr>
+        <p:spPr>
+          <a:xfrm>
+            <a:off x="487680" y="2659713"/>
+            <a:ext cx="11216640" cy="701040"/>
+          </a:xfrm>
+          <a:prstGeom prst="rect">
+            <a:avLst/>
+          </a:prstGeom>
+          <a:solidFill>
+            <a:srgbClr val="1C235A"/>
+          </a:solidFill>
+          <a:ln>
+            <a:noFill/>
+          </a:ln>
+        </p:spPr>
+        <p:style>
+          <a:lnRef idx="1">
+            <a:schemeClr val="accent1"/>
+          </a:lnRef>
+          <a:fillRef idx="3">
+            <a:schemeClr val="accent1"/>
+          </a:fillRef>
+          <a:effectRef idx="2">
+            <a:schemeClr val="accent1"/>
+          </a:effectRef>
+          <a:fontRef idx="minor">
+            <a:schemeClr val="lt1"/>
+          </a:fontRef>
+        </p:style>
+        <p:txBody>
+          <a:bodyPr wrap="square" lIns="60960" tIns="30480" rIns="60960" bIns="30480" rtlCol="0" anchor="ctr">
+            <a:noAutofit/>
+          </a:bodyPr>
+          <a:lstStyle/>
+          <a:p>
+            <a:pPr algn="ctr">
+              <a:defRPr/>
+            </a:pPr>
+            <a:endParaRPr/>
+          </a:p>
+        </p:txBody>
+      </p:sp>
+      <p:sp>
+        <p:nvSpPr>
+          <p:cNvPr id="17" name="Rectangle 16"/>
+          <p:cNvSpPr/>
+          <p:nvPr/>
+        </p:nvSpPr>
+        <p:spPr>
+          <a:xfrm>
+            <a:off x="579120" y="2772355"/>
+            <a:ext cx="396240" cy="396240"/>
+          </a:xfrm>
+          <a:prstGeom prst="rect">
+            <a:avLst/>
+          </a:prstGeom>
+          <a:solidFill>
+            <a:srgbClr val="06B6D4"/>
+          </a:solidFill>
+          <a:ln>
+            <a:noFill/>
+          </a:ln>
+        </p:spPr>
+        <p:style>
+          <a:lnRef idx="1">
+            <a:schemeClr val="accent1"/>
+          </a:lnRef>
+          <a:fillRef idx="3">
+            <a:schemeClr val="accent1"/>
+          </a:fillRef>
+          <a:effectRef idx="2">
+            <a:schemeClr val="accent1"/>
+          </a:effectRef>
+          <a:fontRef idx="minor">
+            <a:schemeClr val="lt1"/>
+          </a:fontRef>
+        </p:style>
+        <p:txBody>
+          <a:bodyPr wrap="square" lIns="60960" tIns="30480" rIns="60960" bIns="30480" rtlCol="0" anchor="ctr">
+            <a:noAutofit/>
+          </a:bodyPr>
+          <a:lstStyle/>
+          <a:p>
+            <a:pPr algn="ctr">
+              <a:defRPr/>
+            </a:pPr>
+            <a:endParaRPr/>
+          </a:p>
+        </p:txBody>
+      </p:sp>
+      <p:sp>
+        <p:nvSpPr>
+          <p:cNvPr id="18" name="TextBox 17"/>
+          <p:cNvSpPr txBox="1"/>
+          <p:nvPr/>
+        </p:nvSpPr>
+        <p:spPr>
+          <a:xfrm>
+            <a:off x="579120" y="2831991"/>
+            <a:ext cx="396240" cy="396240"/>
+          </a:xfrm>
+          <a:prstGeom prst="rect">
+            <a:avLst/>
+          </a:prstGeom>
+          <a:noFill/>
+          <a:ln/>
+        </p:spPr>
+        <p:txBody>
+          <a:bodyPr wrap="square" lIns="60960" tIns="30480" rIns="60960" bIns="30480">
+            <a:noAutofit/>
+          </a:bodyPr>
+          <a:lstStyle/>
+          <a:p>
+            <a:pPr algn="ctr">
+              <a:defRPr/>
+            </a:pPr>
+            <a:r>
+              <a:rPr lang="en-US" sz="1333" b="1" dirty="0">
+                <a:solidFill>
+                  <a:srgbClr val="111848"/>
+                </a:solidFill>
+                <a:latin typeface="Calibri"/>
+              </a:rPr>
+              <a:t>2</a:t>
+            </a:r>
+            <a:endParaRPr sz="1333" b="1" dirty="0">
+              <a:solidFill>
+                <a:srgbClr val="111848"/>
+              </a:solidFill>
+              <a:latin typeface="Calibri"/>
+            </a:endParaRPr>
+          </a:p>
+        </p:txBody>
+      </p:sp>
+      <p:sp>
+        <p:nvSpPr>
+          <p:cNvPr id="19" name="TextBox 18"/>
+          <p:cNvSpPr txBox="1"/>
+          <p:nvPr/>
+        </p:nvSpPr>
+        <p:spPr>
+          <a:xfrm>
+            <a:off x="1097280" y="2820063"/>
+            <a:ext cx="10363200" cy="579120"/>
+          </a:xfrm>
+          <a:prstGeom prst="rect">
+            <a:avLst/>
+          </a:prstGeom>
+          <a:noFill/>
+          <a:ln/>
+        </p:spPr>
+        <p:txBody>
+          <a:bodyPr wrap="square" lIns="60960" tIns="30480" rIns="60960" bIns="30480">
+            <a:noAutofit/>
+          </a:bodyPr>
+          <a:lstStyle/>
+          <a:p>
+            <a:pPr algn="l">
+              <a:defRPr/>
+            </a:pPr>
+            <a:r>
+              <a:rPr sz="1333" b="0">
+                <a:solidFill>
+                  <a:srgbClr val="FFFFFF"/>
+                </a:solidFill>
+                <a:latin typeface="Calibri"/>
+              </a:rPr>
+              <a:t>Garak --list_probes를 실행해 오늘 안 쓴 프로브 1개를 골라 추가 스캔을 돌려보세요.</a:t>
+            </a:r>
+          </a:p>
+        </p:txBody>
+      </p:sp>
+      <p:sp>
+        <p:nvSpPr>
+          <p:cNvPr id="24" name="TextBox 23"/>
+          <p:cNvSpPr txBox="1"/>
+          <p:nvPr/>
+        </p:nvSpPr>
+        <p:spPr>
+          <a:xfrm>
+            <a:off x="0" y="5791200"/>
+            <a:ext cx="12192000" cy="365760"/>
+          </a:xfrm>
+          <a:prstGeom prst="rect">
+            <a:avLst/>
+          </a:prstGeom>
+          <a:noFill/>
+          <a:ln/>
+        </p:spPr>
+        <p:txBody>
+          <a:bodyPr wrap="square" lIns="60960" tIns="30480" rIns="60960" bIns="30480">
+            <a:noAutofit/>
+          </a:bodyPr>
+          <a:lstStyle/>
+          <a:p>
+            <a:pPr algn="ctr">
+              <a:defRPr/>
+            </a:pPr>
+            <a:r>
+              <a:rPr sz="1133" b="0">
+                <a:solidFill>
+                  <a:srgbClr val="F59E0B"/>
+                </a:solidFill>
+                <a:latin typeface="Calibri"/>
+              </a:rPr>
+              <a:t>⚠  합성(가상) 데이터만 사용  —  실제 개인정보·기밀정보 입력 절대 금지</a:t>
+            </a:r>
+          </a:p>
+        </p:txBody>
+      </p:sp>
+    </p:spTree>
+  </p:cSld>
+  <p:clrMapOvr>
+    <a:masterClrMapping/>
+  </p:clrMapOvr>
+</p:sld>
+</file>
+
+<file path=ppt/slides/slide16.xml><?xml version="1.0" encoding="utf-8"?>
 <p:sld xmlns:a="http://schemas.openxmlformats.org/drawingml/2006/main" xmlns:r="http://schemas.openxmlformats.org/officeDocument/2006/relationships" xmlns:p="http://schemas.openxmlformats.org/presentationml/2006/main">
   <p:cSld name="Slide 19">
     <p:bg>
@@ -15958,7 +17916,7 @@
 </p:sld>
 </file>
 
-<file path=ppt/slides/slide15.xml><?xml version="1.0" encoding="utf-8"?>
+<file path=ppt/slides/slide17.xml><?xml version="1.0" encoding="utf-8"?>
 <p:sld xmlns:a="http://schemas.openxmlformats.org/drawingml/2006/main" xmlns:r="http://schemas.openxmlformats.org/officeDocument/2006/relationships" xmlns:p="http://schemas.openxmlformats.org/presentationml/2006/main">
   <p:cSld>
     <p:bg>
@@ -16136,6 +18094,745 @@
 
 <file path=ppt/slides/slide2.xml><?xml version="1.0" encoding="utf-8"?>
 <p:sld xmlns:a="http://schemas.openxmlformats.org/drawingml/2006/main" xmlns:r="http://schemas.openxmlformats.org/officeDocument/2006/relationships" xmlns:p="http://schemas.openxmlformats.org/presentationml/2006/main">
+  <p:cSld>
+    <p:bg>
+      <p:bgPr>
+        <a:solidFill>
+          <a:srgbClr val="F0F2F8"/>
+        </a:solidFill>
+        <a:effectLst/>
+      </p:bgPr>
+    </p:bg>
+    <p:spTree>
+      <p:nvGrpSpPr>
+        <p:cNvPr id="1" name=""/>
+        <p:cNvGrpSpPr/>
+        <p:nvPr/>
+      </p:nvGrpSpPr>
+      <p:grpSpPr>
+        <a:xfrm>
+          <a:off x="0" y="0"/>
+          <a:ext cx="0" cy="0"/>
+          <a:chOff x="0" y="0"/>
+          <a:chExt cx="0" cy="0"/>
+        </a:xfrm>
+      </p:grpSpPr>
+      <p:sp>
+        <p:nvSpPr>
+          <p:cNvPr id="2" name="Rectangle 1"/>
+          <p:cNvSpPr/>
+          <p:nvPr/>
+        </p:nvSpPr>
+        <p:spPr>
+          <a:xfrm>
+            <a:off x="0" y="0"/>
+            <a:ext cx="12192000" cy="670560"/>
+          </a:xfrm>
+          <a:prstGeom prst="rect">
+            <a:avLst/>
+          </a:prstGeom>
+          <a:solidFill>
+            <a:srgbClr val="111848"/>
+          </a:solidFill>
+          <a:ln>
+            <a:noFill/>
+          </a:ln>
+        </p:spPr>
+        <p:style>
+          <a:lnRef idx="1">
+            <a:schemeClr val="accent1"/>
+          </a:lnRef>
+          <a:fillRef idx="3">
+            <a:schemeClr val="accent1"/>
+          </a:fillRef>
+          <a:effectRef idx="2">
+            <a:schemeClr val="accent1"/>
+          </a:effectRef>
+          <a:fontRef idx="minor">
+            <a:schemeClr val="lt1"/>
+          </a:fontRef>
+        </p:style>
+        <p:txBody>
+          <a:bodyPr wrap="square" lIns="60960" tIns="30480" rIns="60960" bIns="30480" rtlCol="0" anchor="ctr">
+            <a:noAutofit/>
+          </a:bodyPr>
+          <a:lstStyle/>
+          <a:p>
+            <a:pPr algn="ctr">
+              <a:defRPr/>
+            </a:pPr>
+            <a:endParaRPr/>
+          </a:p>
+        </p:txBody>
+      </p:sp>
+      <p:sp>
+        <p:nvSpPr>
+          <p:cNvPr id="3" name="TextBox 2"/>
+          <p:cNvSpPr txBox="1"/>
+          <p:nvPr/>
+        </p:nvSpPr>
+        <p:spPr>
+          <a:xfrm>
+            <a:off x="304800" y="0"/>
+            <a:ext cx="11582400" cy="670560"/>
+          </a:xfrm>
+          <a:prstGeom prst="rect">
+            <a:avLst/>
+          </a:prstGeom>
+          <a:noFill/>
+          <a:ln/>
+        </p:spPr>
+        <p:txBody>
+          <a:bodyPr wrap="square" lIns="60960" tIns="30480" rIns="60960" bIns="30480">
+            <a:noAutofit/>
+          </a:bodyPr>
+          <a:lstStyle/>
+          <a:p>
+            <a:pPr algn="l">
+              <a:defRPr/>
+            </a:pPr>
+            <a:r>
+              <a:rPr sz="2000" b="1">
+                <a:solidFill>
+                  <a:srgbClr val="FFFFFF"/>
+                </a:solidFill>
+                <a:latin typeface="Calibri"/>
+              </a:rPr>
+              <a:t>KAIS — 국내 AI 보안 검증 체계</a:t>
+            </a:r>
+          </a:p>
+        </p:txBody>
+      </p:sp>
+      <p:sp>
+        <p:nvSpPr>
+          <p:cNvPr id="4" name="Rectangle 3"/>
+          <p:cNvSpPr/>
+          <p:nvPr/>
+        </p:nvSpPr>
+        <p:spPr>
+          <a:xfrm>
+            <a:off x="304800" y="914400"/>
+            <a:ext cx="3657600" cy="365760"/>
+          </a:xfrm>
+          <a:prstGeom prst="rect">
+            <a:avLst/>
+          </a:prstGeom>
+          <a:solidFill>
+            <a:srgbClr val="3B82F6"/>
+          </a:solidFill>
+          <a:ln>
+            <a:noFill/>
+          </a:ln>
+        </p:spPr>
+        <p:style>
+          <a:lnRef idx="1">
+            <a:schemeClr val="accent1"/>
+          </a:lnRef>
+          <a:fillRef idx="3">
+            <a:schemeClr val="accent1"/>
+          </a:fillRef>
+          <a:effectRef idx="2">
+            <a:schemeClr val="accent1"/>
+          </a:effectRef>
+          <a:fontRef idx="minor">
+            <a:schemeClr val="lt1"/>
+          </a:fontRef>
+        </p:style>
+        <p:txBody>
+          <a:bodyPr wrap="square" lIns="60960" tIns="30480" rIns="60960" bIns="30480" rtlCol="0" anchor="ctr">
+            <a:noAutofit/>
+          </a:bodyPr>
+          <a:lstStyle/>
+          <a:p>
+            <a:pPr algn="ctr">
+              <a:defRPr/>
+            </a:pPr>
+            <a:endParaRPr/>
+          </a:p>
+        </p:txBody>
+      </p:sp>
+      <p:sp>
+        <p:nvSpPr>
+          <p:cNvPr id="5" name="TextBox 4"/>
+          <p:cNvSpPr txBox="1"/>
+          <p:nvPr/>
+        </p:nvSpPr>
+        <p:spPr>
+          <a:xfrm>
+            <a:off x="304800" y="914400"/>
+            <a:ext cx="3657600" cy="365760"/>
+          </a:xfrm>
+          <a:prstGeom prst="rect">
+            <a:avLst/>
+          </a:prstGeom>
+          <a:noFill/>
+          <a:ln/>
+        </p:spPr>
+        <p:txBody>
+          <a:bodyPr wrap="square" lIns="60960" tIns="30480" rIns="60960" bIns="30480">
+            <a:noAutofit/>
+          </a:bodyPr>
+          <a:lstStyle/>
+          <a:p>
+            <a:pPr algn="ctr">
+              <a:defRPr/>
+            </a:pPr>
+            <a:r>
+              <a:rPr sz="1466" b="1">
+                <a:solidFill>
+                  <a:srgbClr val="FFFFFF"/>
+                </a:solidFill>
+                <a:latin typeface="Calibri"/>
+              </a:rPr>
+              <a:t>KAIS란?</a:t>
+            </a:r>
+          </a:p>
+        </p:txBody>
+      </p:sp>
+      <p:sp>
+        <p:nvSpPr>
+          <p:cNvPr id="6" name="Rectangle 5"/>
+          <p:cNvSpPr/>
+          <p:nvPr/>
+        </p:nvSpPr>
+        <p:spPr>
+          <a:xfrm>
+            <a:off x="304800" y="1341120"/>
+            <a:ext cx="3657600" cy="3962400"/>
+          </a:xfrm>
+          <a:prstGeom prst="rect">
+            <a:avLst/>
+          </a:prstGeom>
+          <a:solidFill>
+            <a:srgbClr val="FFFFFF"/>
+          </a:solidFill>
+          <a:ln w="8467">
+            <a:solidFill>
+              <a:srgbClr val="3B82F6"/>
+            </a:solidFill>
+          </a:ln>
+        </p:spPr>
+        <p:style>
+          <a:lnRef idx="1">
+            <a:schemeClr val="accent1"/>
+          </a:lnRef>
+          <a:fillRef idx="3">
+            <a:schemeClr val="accent1"/>
+          </a:fillRef>
+          <a:effectRef idx="2">
+            <a:schemeClr val="accent1"/>
+          </a:effectRef>
+          <a:fontRef idx="minor">
+            <a:schemeClr val="lt1"/>
+          </a:fontRef>
+        </p:style>
+        <p:txBody>
+          <a:bodyPr wrap="square" lIns="60960" tIns="30480" rIns="60960" bIns="30480" rtlCol="0" anchor="ctr">
+            <a:noAutofit/>
+          </a:bodyPr>
+          <a:lstStyle/>
+          <a:p>
+            <a:pPr algn="ctr">
+              <a:defRPr/>
+            </a:pPr>
+            <a:endParaRPr/>
+          </a:p>
+        </p:txBody>
+      </p:sp>
+      <p:sp>
+        <p:nvSpPr>
+          <p:cNvPr id="7" name="TextBox 6"/>
+          <p:cNvSpPr txBox="1"/>
+          <p:nvPr/>
+        </p:nvSpPr>
+        <p:spPr>
+          <a:xfrm>
+            <a:off x="426720" y="1463040"/>
+            <a:ext cx="3413760" cy="3657600"/>
+          </a:xfrm>
+          <a:prstGeom prst="rect">
+            <a:avLst/>
+          </a:prstGeom>
+          <a:noFill/>
+          <a:ln/>
+        </p:spPr>
+        <p:txBody>
+          <a:bodyPr wrap="square" lIns="60960" tIns="30480" rIns="60960" bIns="30480">
+            <a:noAutofit/>
+          </a:bodyPr>
+          <a:lstStyle/>
+          <a:p>
+            <a:pPr algn="l">
+              <a:defRPr/>
+            </a:pPr>
+            <a:r>
+              <a:rPr sz="1200" b="0">
+                <a:solidFill>
+                  <a:srgbClr val="111848"/>
+                </a:solidFill>
+                <a:latin typeface="Calibri"/>
+              </a:rPr>
+              <a:t>Korea AI Safety (KAIS)는 국내 AI 시스템의
+안전성·신뢰성 검증을 위한 정부 주도 이니셔티브.
+• 과기부·KISA 공동 추진
+• AI 서비스 출시 전 보안 점검 프레임워크
+• OWASP LLM + NIS 가이드와 연계</a:t>
+            </a:r>
+          </a:p>
+        </p:txBody>
+      </p:sp>
+      <p:sp>
+        <p:nvSpPr>
+          <p:cNvPr id="8" name="Rectangle 7"/>
+          <p:cNvSpPr/>
+          <p:nvPr/>
+        </p:nvSpPr>
+        <p:spPr>
+          <a:xfrm>
+            <a:off x="4206240" y="914400"/>
+            <a:ext cx="3657600" cy="365760"/>
+          </a:xfrm>
+          <a:prstGeom prst="rect">
+            <a:avLst/>
+          </a:prstGeom>
+          <a:solidFill>
+            <a:srgbClr val="10B981"/>
+          </a:solidFill>
+          <a:ln>
+            <a:noFill/>
+          </a:ln>
+        </p:spPr>
+        <p:style>
+          <a:lnRef idx="1">
+            <a:schemeClr val="accent1"/>
+          </a:lnRef>
+          <a:fillRef idx="3">
+            <a:schemeClr val="accent1"/>
+          </a:fillRef>
+          <a:effectRef idx="2">
+            <a:schemeClr val="accent1"/>
+          </a:effectRef>
+          <a:fontRef idx="minor">
+            <a:schemeClr val="lt1"/>
+          </a:fontRef>
+        </p:style>
+        <p:txBody>
+          <a:bodyPr wrap="square" lIns="60960" tIns="30480" rIns="60960" bIns="30480" rtlCol="0" anchor="ctr">
+            <a:noAutofit/>
+          </a:bodyPr>
+          <a:lstStyle/>
+          <a:p>
+            <a:pPr algn="ctr">
+              <a:defRPr/>
+            </a:pPr>
+            <a:endParaRPr/>
+          </a:p>
+        </p:txBody>
+      </p:sp>
+      <p:sp>
+        <p:nvSpPr>
+          <p:cNvPr id="9" name="TextBox 8"/>
+          <p:cNvSpPr txBox="1"/>
+          <p:nvPr/>
+        </p:nvSpPr>
+        <p:spPr>
+          <a:xfrm>
+            <a:off x="4206240" y="914400"/>
+            <a:ext cx="3657600" cy="365760"/>
+          </a:xfrm>
+          <a:prstGeom prst="rect">
+            <a:avLst/>
+          </a:prstGeom>
+          <a:noFill/>
+          <a:ln/>
+        </p:spPr>
+        <p:txBody>
+          <a:bodyPr wrap="square" lIns="60960" tIns="30480" rIns="60960" bIns="30480">
+            <a:noAutofit/>
+          </a:bodyPr>
+          <a:lstStyle/>
+          <a:p>
+            <a:pPr algn="ctr">
+              <a:defRPr/>
+            </a:pPr>
+            <a:r>
+              <a:rPr sz="1466" b="1">
+                <a:solidFill>
+                  <a:srgbClr val="FFFFFF"/>
+                </a:solidFill>
+                <a:latin typeface="Calibri"/>
+              </a:rPr>
+              <a:t>Garak과의 연결</a:t>
+            </a:r>
+          </a:p>
+        </p:txBody>
+      </p:sp>
+      <p:sp>
+        <p:nvSpPr>
+          <p:cNvPr id="10" name="Rectangle 9"/>
+          <p:cNvSpPr/>
+          <p:nvPr/>
+        </p:nvSpPr>
+        <p:spPr>
+          <a:xfrm>
+            <a:off x="4206240" y="1341120"/>
+            <a:ext cx="3657600" cy="3962400"/>
+          </a:xfrm>
+          <a:prstGeom prst="rect">
+            <a:avLst/>
+          </a:prstGeom>
+          <a:solidFill>
+            <a:srgbClr val="FFFFFF"/>
+          </a:solidFill>
+          <a:ln w="8467">
+            <a:solidFill>
+              <a:srgbClr val="10B981"/>
+            </a:solidFill>
+          </a:ln>
+        </p:spPr>
+        <p:style>
+          <a:lnRef idx="1">
+            <a:schemeClr val="accent1"/>
+          </a:lnRef>
+          <a:fillRef idx="3">
+            <a:schemeClr val="accent1"/>
+          </a:fillRef>
+          <a:effectRef idx="2">
+            <a:schemeClr val="accent1"/>
+          </a:effectRef>
+          <a:fontRef idx="minor">
+            <a:schemeClr val="lt1"/>
+          </a:fontRef>
+        </p:style>
+        <p:txBody>
+          <a:bodyPr wrap="square" lIns="60960" tIns="30480" rIns="60960" bIns="30480" rtlCol="0" anchor="ctr">
+            <a:noAutofit/>
+          </a:bodyPr>
+          <a:lstStyle/>
+          <a:p>
+            <a:pPr algn="ctr">
+              <a:defRPr/>
+            </a:pPr>
+            <a:endParaRPr/>
+          </a:p>
+        </p:txBody>
+      </p:sp>
+      <p:sp>
+        <p:nvSpPr>
+          <p:cNvPr id="11" name="TextBox 10"/>
+          <p:cNvSpPr txBox="1"/>
+          <p:nvPr/>
+        </p:nvSpPr>
+        <p:spPr>
+          <a:xfrm>
+            <a:off x="4328160" y="1463040"/>
+            <a:ext cx="3413760" cy="3657600"/>
+          </a:xfrm>
+          <a:prstGeom prst="rect">
+            <a:avLst/>
+          </a:prstGeom>
+          <a:noFill/>
+          <a:ln/>
+        </p:spPr>
+        <p:txBody>
+          <a:bodyPr wrap="square" lIns="60960" tIns="30480" rIns="60960" bIns="30480">
+            <a:noAutofit/>
+          </a:bodyPr>
+          <a:lstStyle/>
+          <a:p>
+            <a:pPr algn="l">
+              <a:defRPr/>
+            </a:pPr>
+            <a:r>
+              <a:rPr sz="1200" b="0">
+                <a:solidFill>
+                  <a:srgbClr val="111848"/>
+                </a:solidFill>
+                <a:latin typeface="Calibri"/>
+              </a:rPr>
+              <a:t>KAIS 검증 항목 ↔ Garak 프로브 매핑:
+• 프롬프트 인젝션 → dan, promptinject 프로브
+• 데이터 유출 → encoding, latentinjection
+• 독성 콘텐츠 → lmrc, realtoxicity
+→ Garak = KAIS 자동화 레드팀 도구</a:t>
+            </a:r>
+          </a:p>
+        </p:txBody>
+      </p:sp>
+      <p:sp>
+        <p:nvSpPr>
+          <p:cNvPr id="12" name="Rectangle 11"/>
+          <p:cNvSpPr/>
+          <p:nvPr/>
+        </p:nvSpPr>
+        <p:spPr>
+          <a:xfrm>
+            <a:off x="8107680" y="914400"/>
+            <a:ext cx="3657600" cy="365760"/>
+          </a:xfrm>
+          <a:prstGeom prst="rect">
+            <a:avLst/>
+          </a:prstGeom>
+          <a:solidFill>
+            <a:srgbClr val="F59E0B"/>
+          </a:solidFill>
+          <a:ln>
+            <a:noFill/>
+          </a:ln>
+        </p:spPr>
+        <p:style>
+          <a:lnRef idx="1">
+            <a:schemeClr val="accent1"/>
+          </a:lnRef>
+          <a:fillRef idx="3">
+            <a:schemeClr val="accent1"/>
+          </a:fillRef>
+          <a:effectRef idx="2">
+            <a:schemeClr val="accent1"/>
+          </a:effectRef>
+          <a:fontRef idx="minor">
+            <a:schemeClr val="lt1"/>
+          </a:fontRef>
+        </p:style>
+        <p:txBody>
+          <a:bodyPr wrap="square" lIns="60960" tIns="30480" rIns="60960" bIns="30480" rtlCol="0" anchor="ctr">
+            <a:noAutofit/>
+          </a:bodyPr>
+          <a:lstStyle/>
+          <a:p>
+            <a:pPr algn="ctr">
+              <a:defRPr/>
+            </a:pPr>
+            <a:endParaRPr/>
+          </a:p>
+        </p:txBody>
+      </p:sp>
+      <p:sp>
+        <p:nvSpPr>
+          <p:cNvPr id="13" name="TextBox 12"/>
+          <p:cNvSpPr txBox="1"/>
+          <p:nvPr/>
+        </p:nvSpPr>
+        <p:spPr>
+          <a:xfrm>
+            <a:off x="8107680" y="914400"/>
+            <a:ext cx="3657600" cy="365760"/>
+          </a:xfrm>
+          <a:prstGeom prst="rect">
+            <a:avLst/>
+          </a:prstGeom>
+          <a:noFill/>
+          <a:ln/>
+        </p:spPr>
+        <p:txBody>
+          <a:bodyPr wrap="square" lIns="60960" tIns="30480" rIns="60960" bIns="30480">
+            <a:noAutofit/>
+          </a:bodyPr>
+          <a:lstStyle/>
+          <a:p>
+            <a:pPr algn="ctr">
+              <a:defRPr/>
+            </a:pPr>
+            <a:r>
+              <a:rPr sz="1466" b="1">
+                <a:solidFill>
+                  <a:srgbClr val="FFFFFF"/>
+                </a:solidFill>
+                <a:latin typeface="Calibri"/>
+              </a:rPr>
+              <a:t>실습 연계</a:t>
+            </a:r>
+          </a:p>
+        </p:txBody>
+      </p:sp>
+      <p:sp>
+        <p:nvSpPr>
+          <p:cNvPr id="14" name="Rectangle 13"/>
+          <p:cNvSpPr/>
+          <p:nvPr/>
+        </p:nvSpPr>
+        <p:spPr>
+          <a:xfrm>
+            <a:off x="8107680" y="1341120"/>
+            <a:ext cx="3657600" cy="3962400"/>
+          </a:xfrm>
+          <a:prstGeom prst="rect">
+            <a:avLst/>
+          </a:prstGeom>
+          <a:solidFill>
+            <a:srgbClr val="FFFFFF"/>
+          </a:solidFill>
+          <a:ln w="8467">
+            <a:solidFill>
+              <a:srgbClr val="F59E0B"/>
+            </a:solidFill>
+          </a:ln>
+        </p:spPr>
+        <p:style>
+          <a:lnRef idx="1">
+            <a:schemeClr val="accent1"/>
+          </a:lnRef>
+          <a:fillRef idx="3">
+            <a:schemeClr val="accent1"/>
+          </a:fillRef>
+          <a:effectRef idx="2">
+            <a:schemeClr val="accent1"/>
+          </a:effectRef>
+          <a:fontRef idx="minor">
+            <a:schemeClr val="lt1"/>
+          </a:fontRef>
+        </p:style>
+        <p:txBody>
+          <a:bodyPr wrap="square" lIns="60960" tIns="30480" rIns="60960" bIns="30480" rtlCol="0" anchor="ctr">
+            <a:noAutofit/>
+          </a:bodyPr>
+          <a:lstStyle/>
+          <a:p>
+            <a:pPr algn="ctr">
+              <a:defRPr/>
+            </a:pPr>
+            <a:endParaRPr/>
+          </a:p>
+        </p:txBody>
+      </p:sp>
+      <p:sp>
+        <p:nvSpPr>
+          <p:cNvPr id="15" name="TextBox 14"/>
+          <p:cNvSpPr txBox="1"/>
+          <p:nvPr/>
+        </p:nvSpPr>
+        <p:spPr>
+          <a:xfrm>
+            <a:off x="8229600" y="1463040"/>
+            <a:ext cx="3413760" cy="3657600"/>
+          </a:xfrm>
+          <a:prstGeom prst="rect">
+            <a:avLst/>
+          </a:prstGeom>
+          <a:noFill/>
+          <a:ln/>
+        </p:spPr>
+        <p:txBody>
+          <a:bodyPr wrap="square" lIns="60960" tIns="30480" rIns="60960" bIns="30480">
+            <a:noAutofit/>
+          </a:bodyPr>
+          <a:lstStyle/>
+          <a:p>
+            <a:pPr algn="l">
+              <a:defRPr/>
+            </a:pPr>
+            <a:r>
+              <a:rPr sz="1200" b="0">
+                <a:solidFill>
+                  <a:srgbClr val="111848"/>
+                </a:solidFill>
+                <a:latin typeface="Calibri"/>
+              </a:rPr>
+              <a:t>오늘 실습3에서 수행하는 것:
+• Garak으로 6종 프로브 자동 스캔
+• KAIS 점검 항목에 해당하는 취약점 탐지
+• 한국어 도메인 맞춤 커스텀 프로브
+→ 기관 복귀 후 즉시 적용 가능</a:t>
+            </a:r>
+          </a:p>
+        </p:txBody>
+      </p:sp>
+      <p:sp>
+        <p:nvSpPr>
+          <p:cNvPr id="16" name="Rectangle 15"/>
+          <p:cNvSpPr/>
+          <p:nvPr/>
+        </p:nvSpPr>
+        <p:spPr>
+          <a:xfrm>
+            <a:off x="304800" y="5547360"/>
+            <a:ext cx="11582400" cy="426720"/>
+          </a:xfrm>
+          <a:prstGeom prst="rect">
+            <a:avLst/>
+          </a:prstGeom>
+          <a:solidFill>
+            <a:srgbClr val="E0F2FE"/>
+          </a:solidFill>
+          <a:ln>
+            <a:noFill/>
+          </a:ln>
+        </p:spPr>
+        <p:style>
+          <a:lnRef idx="1">
+            <a:schemeClr val="accent1"/>
+          </a:lnRef>
+          <a:fillRef idx="3">
+            <a:schemeClr val="accent1"/>
+          </a:fillRef>
+          <a:effectRef idx="2">
+            <a:schemeClr val="accent1"/>
+          </a:effectRef>
+          <a:fontRef idx="minor">
+            <a:schemeClr val="lt1"/>
+          </a:fontRef>
+        </p:style>
+        <p:txBody>
+          <a:bodyPr wrap="square" lIns="60960" tIns="30480" rIns="60960" bIns="30480" rtlCol="0" anchor="ctr">
+            <a:noAutofit/>
+          </a:bodyPr>
+          <a:lstStyle/>
+          <a:p>
+            <a:pPr algn="ctr">
+              <a:defRPr/>
+            </a:pPr>
+            <a:endParaRPr/>
+          </a:p>
+        </p:txBody>
+      </p:sp>
+      <p:sp>
+        <p:nvSpPr>
+          <p:cNvPr id="17" name="TextBox 16"/>
+          <p:cNvSpPr txBox="1"/>
+          <p:nvPr/>
+        </p:nvSpPr>
+        <p:spPr>
+          <a:xfrm>
+            <a:off x="487680" y="5547360"/>
+            <a:ext cx="11277600" cy="426720"/>
+          </a:xfrm>
+          <a:prstGeom prst="rect">
+            <a:avLst/>
+          </a:prstGeom>
+          <a:noFill/>
+          <a:ln/>
+        </p:spPr>
+        <p:txBody>
+          <a:bodyPr wrap="square" lIns="60960" tIns="30480" rIns="60960" bIns="30480">
+            <a:noAutofit/>
+          </a:bodyPr>
+          <a:lstStyle/>
+          <a:p>
+            <a:pPr algn="ctr">
+              <a:defRPr/>
+            </a:pPr>
+            <a:r>
+              <a:rPr sz="1333" b="1">
+                <a:solidFill>
+                  <a:srgbClr val="111848"/>
+                </a:solidFill>
+                <a:latin typeface="Calibri"/>
+              </a:rPr>
+              <a:t>결론: NIS·KISA 이론(슬롯1·2) → Garak 자동 검증(슬롯5) — 한 사이클이 완성됩니다</a:t>
+            </a:r>
+          </a:p>
+        </p:txBody>
+      </p:sp>
+    </p:spTree>
+  </p:cSld>
+  <p:clrMapOvr>
+    <a:masterClrMapping/>
+  </p:clrMapOvr>
+</p:sld>
+</file>
+
+<file path=ppt/slides/slide3.xml><?xml version="1.0" encoding="utf-8"?>
+<p:sld xmlns:a="http://schemas.openxmlformats.org/drawingml/2006/main" xmlns:r="http://schemas.openxmlformats.org/officeDocument/2006/relationships" xmlns:p="http://schemas.openxmlformats.org/presentationml/2006/main">
   <p:cSld name="Slide 2">
     <p:bg>
       <p:bgPr>
@@ -17946,7 +20643,7 @@
 </p:sld>
 </file>
 
-<file path=ppt/slides/slide3.xml><?xml version="1.0" encoding="utf-8"?>
+<file path=ppt/slides/slide4.xml><?xml version="1.0" encoding="utf-8"?>
 <p:sld xmlns:a="http://schemas.openxmlformats.org/drawingml/2006/main" xmlns:r="http://schemas.openxmlformats.org/officeDocument/2006/relationships" xmlns:p="http://schemas.openxmlformats.org/presentationml/2006/main">
   <p:cSld name="Slide 3">
     <p:bg>
@@ -19683,7 +22380,7 @@
 </p:sld>
 </file>
 
-<file path=ppt/slides/slide4.xml><?xml version="1.0" encoding="utf-8"?>
+<file path=ppt/slides/slide5.xml><?xml version="1.0" encoding="utf-8"?>
 <p:sld xmlns:a="http://schemas.openxmlformats.org/drawingml/2006/main" xmlns:r="http://schemas.openxmlformats.org/officeDocument/2006/relationships" xmlns:p="http://schemas.openxmlformats.org/presentationml/2006/main">
   <p:cSld name="Slide 4">
     <p:bg>
@@ -21242,7 +23939,7 @@
 </p:sld>
 </file>
 
-<file path=ppt/slides/slide5.xml><?xml version="1.0" encoding="utf-8"?>
+<file path=ppt/slides/slide6.xml><?xml version="1.0" encoding="utf-8"?>
 <p:sld xmlns:a="http://schemas.openxmlformats.org/drawingml/2006/main" xmlns:r="http://schemas.openxmlformats.org/officeDocument/2006/relationships" xmlns:p="http://schemas.openxmlformats.org/presentationml/2006/main">
   <p:cSld name="Slide 5">
     <p:bg>
@@ -22361,7 +25058,7 @@
 </p:sld>
 </file>
 
-<file path=ppt/slides/slide6.xml><?xml version="1.0" encoding="utf-8"?>
+<file path=ppt/slides/slide7.xml><?xml version="1.0" encoding="utf-8"?>
 <p:sld xmlns:a="http://schemas.openxmlformats.org/drawingml/2006/main" xmlns:r="http://schemas.openxmlformats.org/officeDocument/2006/relationships" xmlns:p="http://schemas.openxmlformats.org/presentationml/2006/main">
   <p:cSld name="Slide 6">
     <p:bg>
@@ -23574,7 +26271,7 @@
 </p:sld>
 </file>
 
-<file path=ppt/slides/slide7.xml><?xml version="1.0" encoding="utf-8"?>
+<file path=ppt/slides/slide8.xml><?xml version="1.0" encoding="utf-8"?>
 <p:sld xmlns:a="http://schemas.openxmlformats.org/drawingml/2006/main" xmlns:r="http://schemas.openxmlformats.org/officeDocument/2006/relationships" xmlns:p="http://schemas.openxmlformats.org/presentationml/2006/main">
   <p:cSld name="Slide 7">
     <p:bg>
@@ -25388,7 +28085,7 @@
 </p:sld>
 </file>
 
-<file path=ppt/slides/slide8.xml><?xml version="1.0" encoding="utf-8"?>
+<file path=ppt/slides/slide9.xml><?xml version="1.0" encoding="utf-8"?>
 <p:sld xmlns:a="http://schemas.openxmlformats.org/drawingml/2006/main" xmlns:r="http://schemas.openxmlformats.org/officeDocument/2006/relationships" xmlns:p="http://schemas.openxmlformats.org/presentationml/2006/main">
   <p:cSld name="Slide 8">
     <p:bg>
@@ -26088,1403 +28785,6 @@
                 <a:cs typeface="Arial" pitchFamily="34" charset="-120"/>
               </a:rPr>
               <a:t>8 / 19</a:t>
-            </a:r>
-            <a:endParaRPr lang="en-US" sz="900" dirty="0"/>
-          </a:p>
-        </p:txBody>
-      </p:sp>
-    </p:spTree>
-  </p:cSld>
-  <p:clrMapOvr>
-    <a:masterClrMapping/>
-  </p:clrMapOvr>
-</p:sld>
-</file>
-
-<file path=ppt/slides/slide9.xml><?xml version="1.0" encoding="utf-8"?>
-<p:sld xmlns:a="http://schemas.openxmlformats.org/drawingml/2006/main" xmlns:r="http://schemas.openxmlformats.org/officeDocument/2006/relationships" xmlns:p="http://schemas.openxmlformats.org/presentationml/2006/main">
-  <p:cSld name="Slide 9">
-    <p:bg>
-      <p:bgPr>
-        <a:solidFill>
-          <a:srgbClr val="FFFFFF"/>
-        </a:solidFill>
-        <a:effectLst/>
-      </p:bgPr>
-    </p:bg>
-    <p:spTree>
-      <p:nvGrpSpPr>
-        <p:cNvPr id="1" name=""/>
-        <p:cNvGrpSpPr/>
-        <p:nvPr/>
-      </p:nvGrpSpPr>
-      <p:grpSpPr>
-        <a:xfrm>
-          <a:off x="0" y="0"/>
-          <a:ext cx="0" cy="0"/>
-          <a:chOff x="0" y="0"/>
-          <a:chExt cx="0" cy="0"/>
-        </a:xfrm>
-      </p:grpSpPr>
-      <p:sp>
-        <p:nvSpPr>
-          <p:cNvPr id="2" name="Text 0"/>
-          <p:cNvSpPr/>
-          <p:nvPr/>
-        </p:nvSpPr>
-        <p:spPr>
-          <a:xfrm>
-            <a:off x="365760" y="228600"/>
-            <a:ext cx="10972800" cy="365760"/>
-          </a:xfrm>
-          <a:prstGeom prst="rect">
-            <a:avLst/>
-          </a:prstGeom>
-          <a:noFill/>
-          <a:ln/>
-        </p:spPr>
-        <p:txBody>
-          <a:bodyPr wrap="square" lIns="0" tIns="0" rIns="0" bIns="0" rtlCol="0" anchor="ctr"/>
-          <a:lstStyle/>
-          <a:p>
-            <a:pPr marL="0" indent="0">
-              <a:buNone/>
-            </a:pPr>
-            <a:r>
-              <a:rPr lang="en-US" sz="1500" b="1" dirty="0">
-                <a:solidFill>
-                  <a:srgbClr val="111848"/>
-                </a:solidFill>
-                <a:latin typeface="Arial" pitchFamily="34" charset="0"/>
-                <a:ea typeface="Arial" pitchFamily="34" charset="-122"/>
-                <a:cs typeface="Arial" pitchFamily="34" charset="-120"/>
-              </a:rPr>
-              <a:t>🎯 Step B-1 — eval 엔트리 파싱 (프로브별 PASS/FAIL 요약)</a:t>
-            </a:r>
-            <a:endParaRPr lang="en-US" sz="1500" dirty="0"/>
-          </a:p>
-        </p:txBody>
-      </p:sp>
-      <p:sp>
-        <p:nvSpPr>
-          <p:cNvPr id="3" name="Shape 1"/>
-          <p:cNvSpPr/>
-          <p:nvPr/>
-        </p:nvSpPr>
-        <p:spPr>
-          <a:xfrm>
-            <a:off x="274320" y="548640"/>
-            <a:ext cx="11612880" cy="36576"/>
-          </a:xfrm>
-          <a:prstGeom prst="rect">
-            <a:avLst/>
-          </a:prstGeom>
-          <a:solidFill>
-            <a:srgbClr val="7C3AED"/>
-          </a:solidFill>
-          <a:ln w="12700">
-            <a:solidFill>
-              <a:srgbClr val="333333"/>
-            </a:solidFill>
-            <a:prstDash val="solid"/>
-          </a:ln>
-        </p:spPr>
-        <p:txBody>
-          <a:bodyPr/>
-          <a:lstStyle/>
-          <a:p>
-            <a:endParaRPr lang="ko-KR" altLang="en-US"/>
-          </a:p>
-        </p:txBody>
-      </p:sp>
-      <p:sp>
-        <p:nvSpPr>
-          <p:cNvPr id="4" name="Shape 2"/>
-          <p:cNvSpPr/>
-          <p:nvPr/>
-        </p:nvSpPr>
-        <p:spPr>
-          <a:xfrm>
-            <a:off x="274320" y="640080"/>
-            <a:ext cx="5303520" cy="1417320"/>
-          </a:xfrm>
-          <a:prstGeom prst="rect">
-            <a:avLst/>
-          </a:prstGeom>
-          <a:solidFill>
-            <a:srgbClr val="FFFFFF"/>
-          </a:solidFill>
-          <a:ln w="15240">
-            <a:solidFill>
-              <a:srgbClr val="7C3AED"/>
-            </a:solidFill>
-            <a:prstDash val="solid"/>
-          </a:ln>
-          <a:effectLst>
-            <a:outerShdw blurRad="63500" dist="25400" dir="8100000" algn="bl" rotWithShape="0">
-              <a:srgbClr val="000000">
-                <a:alpha val="10000"/>
-              </a:srgbClr>
-            </a:outerShdw>
-          </a:effectLst>
-        </p:spPr>
-        <p:txBody>
-          <a:bodyPr/>
-          <a:lstStyle/>
-          <a:p>
-            <a:endParaRPr lang="ko-KR" altLang="en-US"/>
-          </a:p>
-        </p:txBody>
-      </p:sp>
-      <p:sp>
-        <p:nvSpPr>
-          <p:cNvPr id="5" name="Shape 3"/>
-          <p:cNvSpPr/>
-          <p:nvPr/>
-        </p:nvSpPr>
-        <p:spPr>
-          <a:xfrm>
-            <a:off x="274320" y="640080"/>
-            <a:ext cx="5303520" cy="329184"/>
-          </a:xfrm>
-          <a:prstGeom prst="rect">
-            <a:avLst/>
-          </a:prstGeom>
-          <a:solidFill>
-            <a:srgbClr val="7C3AED"/>
-          </a:solidFill>
-          <a:ln w="12700">
-            <a:solidFill>
-              <a:srgbClr val="7C3AED"/>
-            </a:solidFill>
-            <a:prstDash val="solid"/>
-          </a:ln>
-        </p:spPr>
-        <p:txBody>
-          <a:bodyPr/>
-          <a:lstStyle/>
-          <a:p>
-            <a:endParaRPr lang="ko-KR" altLang="en-US"/>
-          </a:p>
-        </p:txBody>
-      </p:sp>
-      <p:sp>
-        <p:nvSpPr>
-          <p:cNvPr id="6" name="Text 4"/>
-          <p:cNvSpPr/>
-          <p:nvPr/>
-        </p:nvSpPr>
-        <p:spPr>
-          <a:xfrm>
-            <a:off x="384048" y="640080"/>
-            <a:ext cx="5084064" cy="329184"/>
-          </a:xfrm>
-          <a:prstGeom prst="rect">
-            <a:avLst/>
-          </a:prstGeom>
-          <a:noFill/>
-          <a:ln/>
-        </p:spPr>
-        <p:txBody>
-          <a:bodyPr wrap="square" lIns="0" tIns="0" rIns="0" bIns="0" rtlCol="0" anchor="ctr"/>
-          <a:lstStyle/>
-          <a:p>
-            <a:pPr marL="0" indent="0">
-              <a:buNone/>
-            </a:pPr>
-            <a:r>
-              <a:rPr lang="en-US" sz="1100" b="1" dirty="0">
-                <a:solidFill>
-                  <a:srgbClr val="FFFFFF"/>
-                </a:solidFill>
-                <a:latin typeface="Arial" pitchFamily="34" charset="0"/>
-                <a:ea typeface="Arial" pitchFamily="34" charset="-122"/>
-                <a:cs typeface="Arial" pitchFamily="34" charset="-120"/>
-              </a:rPr>
-              <a:t>JSONL 파일 위치 확인</a:t>
-            </a:r>
-            <a:endParaRPr lang="en-US" sz="1100" dirty="0"/>
-          </a:p>
-        </p:txBody>
-      </p:sp>
-      <p:sp>
-        <p:nvSpPr>
-          <p:cNvPr id="7" name="Text 5"/>
-          <p:cNvSpPr/>
-          <p:nvPr/>
-        </p:nvSpPr>
-        <p:spPr>
-          <a:xfrm>
-            <a:off x="411480" y="1042416"/>
-            <a:ext cx="5029200" cy="246888"/>
-          </a:xfrm>
-          <a:prstGeom prst="rect">
-            <a:avLst/>
-          </a:prstGeom>
-          <a:noFill/>
-          <a:ln/>
-        </p:spPr>
-        <p:txBody>
-          <a:bodyPr wrap="square" rtlCol="0" anchor="ctr"/>
-          <a:lstStyle/>
-          <a:p>
-            <a:pPr marL="0" indent="0">
-              <a:buNone/>
-            </a:pPr>
-            <a:r>
-              <a:rPr lang="en-US" sz="1000" dirty="0">
-                <a:solidFill>
-                  <a:srgbClr val="111848"/>
-                </a:solidFill>
-                <a:latin typeface="Arial" pitchFamily="34" charset="0"/>
-                <a:ea typeface="Arial" pitchFamily="34" charset="-122"/>
-                <a:cs typeface="Arial" pitchFamily="34" charset="-120"/>
-              </a:rPr>
-              <a:t>실습 A 완료 후 GARAK_RUNS 경로에 저장됨</a:t>
-            </a:r>
-            <a:endParaRPr lang="en-US" sz="1000" dirty="0"/>
-          </a:p>
-        </p:txBody>
-      </p:sp>
-      <p:sp>
-        <p:nvSpPr>
-          <p:cNvPr id="8" name="Text 6"/>
-          <p:cNvSpPr/>
-          <p:nvPr/>
-        </p:nvSpPr>
-        <p:spPr>
-          <a:xfrm>
-            <a:off x="411480" y="1316736"/>
-            <a:ext cx="5029200" cy="246888"/>
-          </a:xfrm>
-          <a:prstGeom prst="rect">
-            <a:avLst/>
-          </a:prstGeom>
-          <a:noFill/>
-          <a:ln/>
-        </p:spPr>
-        <p:txBody>
-          <a:bodyPr wrap="square" rtlCol="0" anchor="ctr"/>
-          <a:lstStyle/>
-          <a:p>
-            <a:pPr marL="0" indent="0">
-              <a:buNone/>
-            </a:pPr>
-            <a:r>
-              <a:rPr lang="en-US" sz="1000" dirty="0">
-                <a:solidFill>
-                  <a:srgbClr val="111848"/>
-                </a:solidFill>
-                <a:latin typeface="Arial" pitchFamily="34" charset="0"/>
-                <a:ea typeface="Arial" pitchFamily="34" charset="-122"/>
-                <a:cs typeface="Arial" pitchFamily="34" charset="-120"/>
-              </a:rPr>
-              <a:t>*.report.jsonl — 전체 로그</a:t>
-            </a:r>
-            <a:endParaRPr lang="en-US" sz="1000" dirty="0"/>
-          </a:p>
-        </p:txBody>
-      </p:sp>
-      <p:sp>
-        <p:nvSpPr>
-          <p:cNvPr id="9" name="Shape 7"/>
-          <p:cNvSpPr/>
-          <p:nvPr/>
-        </p:nvSpPr>
-        <p:spPr>
-          <a:xfrm>
-            <a:off x="274320" y="2176272"/>
-            <a:ext cx="5303520" cy="1417320"/>
-          </a:xfrm>
-          <a:prstGeom prst="rect">
-            <a:avLst/>
-          </a:prstGeom>
-          <a:solidFill>
-            <a:srgbClr val="FFFFFF"/>
-          </a:solidFill>
-          <a:ln w="15240">
-            <a:solidFill>
-              <a:srgbClr val="2563EB"/>
-            </a:solidFill>
-            <a:prstDash val="solid"/>
-          </a:ln>
-          <a:effectLst>
-            <a:outerShdw blurRad="63500" dist="25400" dir="8100000" algn="bl" rotWithShape="0">
-              <a:srgbClr val="000000">
-                <a:alpha val="10000"/>
-              </a:srgbClr>
-            </a:outerShdw>
-          </a:effectLst>
-        </p:spPr>
-        <p:txBody>
-          <a:bodyPr/>
-          <a:lstStyle/>
-          <a:p>
-            <a:endParaRPr lang="ko-KR" altLang="en-US" dirty="0"/>
-          </a:p>
-        </p:txBody>
-      </p:sp>
-      <p:sp>
-        <p:nvSpPr>
-          <p:cNvPr id="10" name="Shape 8"/>
-          <p:cNvSpPr/>
-          <p:nvPr/>
-        </p:nvSpPr>
-        <p:spPr>
-          <a:xfrm>
-            <a:off x="274320" y="2176272"/>
-            <a:ext cx="5303520" cy="329184"/>
-          </a:xfrm>
-          <a:prstGeom prst="rect">
-            <a:avLst/>
-          </a:prstGeom>
-          <a:solidFill>
-            <a:srgbClr val="2563EB"/>
-          </a:solidFill>
-          <a:ln w="12700">
-            <a:solidFill>
-              <a:srgbClr val="2563EB"/>
-            </a:solidFill>
-            <a:prstDash val="solid"/>
-          </a:ln>
-        </p:spPr>
-        <p:txBody>
-          <a:bodyPr/>
-          <a:lstStyle/>
-          <a:p>
-            <a:endParaRPr lang="ko-KR" altLang="en-US"/>
-          </a:p>
-        </p:txBody>
-      </p:sp>
-      <p:sp>
-        <p:nvSpPr>
-          <p:cNvPr id="11" name="Text 9"/>
-          <p:cNvSpPr/>
-          <p:nvPr/>
-        </p:nvSpPr>
-        <p:spPr>
-          <a:xfrm>
-            <a:off x="384048" y="2176272"/>
-            <a:ext cx="5084064" cy="329184"/>
-          </a:xfrm>
-          <a:prstGeom prst="rect">
-            <a:avLst/>
-          </a:prstGeom>
-          <a:noFill/>
-          <a:ln/>
-        </p:spPr>
-        <p:txBody>
-          <a:bodyPr wrap="square" lIns="0" tIns="0" rIns="0" bIns="0" rtlCol="0" anchor="ctr"/>
-          <a:lstStyle/>
-          <a:p>
-            <a:pPr marL="0" indent="0">
-              <a:buNone/>
-            </a:pPr>
-            <a:r>
-              <a:rPr lang="en-US" sz="1100" b="1" dirty="0">
-                <a:solidFill>
-                  <a:srgbClr val="FFFFFF"/>
-                </a:solidFill>
-                <a:latin typeface="Arial" pitchFamily="34" charset="0"/>
-                <a:ea typeface="Arial" pitchFamily="34" charset="-122"/>
-                <a:cs typeface="Arial" pitchFamily="34" charset="-120"/>
-              </a:rPr>
-              <a:t>분석 목표</a:t>
-            </a:r>
-            <a:endParaRPr lang="en-US" sz="1100" dirty="0"/>
-          </a:p>
-        </p:txBody>
-      </p:sp>
-      <p:sp>
-        <p:nvSpPr>
-          <p:cNvPr id="12" name="Text 10"/>
-          <p:cNvSpPr/>
-          <p:nvPr/>
-        </p:nvSpPr>
-        <p:spPr>
-          <a:xfrm>
-            <a:off x="411480" y="2578608"/>
-            <a:ext cx="5029200" cy="246888"/>
-          </a:xfrm>
-          <a:prstGeom prst="rect">
-            <a:avLst/>
-          </a:prstGeom>
-          <a:noFill/>
-          <a:ln/>
-        </p:spPr>
-        <p:txBody>
-          <a:bodyPr wrap="square" rtlCol="0" anchor="ctr"/>
-          <a:lstStyle/>
-          <a:p>
-            <a:pPr marL="0" indent="0">
-              <a:buNone/>
-            </a:pPr>
-            <a:r>
-              <a:rPr lang="en-US" sz="1000" dirty="0">
-                <a:solidFill>
-                  <a:srgbClr val="111848"/>
-                </a:solidFill>
-                <a:latin typeface="Arial" pitchFamily="34" charset="0"/>
-                <a:ea typeface="Arial" pitchFamily="34" charset="-122"/>
-                <a:cs typeface="Arial" pitchFamily="34" charset="-120"/>
-              </a:rPr>
-              <a:t>① 프로브별 PASS/FAIL 비율 집계</a:t>
-            </a:r>
-            <a:endParaRPr lang="en-US" sz="1000" dirty="0"/>
-          </a:p>
-        </p:txBody>
-      </p:sp>
-      <p:sp>
-        <p:nvSpPr>
-          <p:cNvPr id="14" name="Text 12"/>
-          <p:cNvSpPr/>
-          <p:nvPr/>
-        </p:nvSpPr>
-        <p:spPr>
-          <a:xfrm>
-            <a:off x="411480" y="3127248"/>
-            <a:ext cx="5029200" cy="246888"/>
-          </a:xfrm>
-          <a:prstGeom prst="rect">
-            <a:avLst/>
-          </a:prstGeom>
-          <a:noFill/>
-          <a:ln/>
-        </p:spPr>
-        <p:txBody>
-          <a:bodyPr wrap="square" rtlCol="0" anchor="ctr"/>
-          <a:lstStyle/>
-          <a:p>
-            <a:pPr marL="0" indent="0">
-              <a:buNone/>
-            </a:pPr>
-            <a:r>
-              <a:rPr lang="en-US" sz="1000" b="1" dirty="0">
-                <a:solidFill>
-                  <a:srgbClr val="2563EB"/>
-                </a:solidFill>
-                <a:latin typeface="Arial" pitchFamily="34" charset="0"/>
-                <a:ea typeface="Arial" pitchFamily="34" charset="-122"/>
-                <a:cs typeface="Arial" pitchFamily="34" charset="-120"/>
-              </a:rPr>
-              <a:t>→ 자동화 도구로 수동 테스트 대비 커버리지 비교</a:t>
-            </a:r>
-            <a:endParaRPr lang="en-US" sz="1000" dirty="0"/>
-          </a:p>
-        </p:txBody>
-      </p:sp>
-      <p:sp>
-        <p:nvSpPr>
-          <p:cNvPr id="15" name="Text 13"/>
-          <p:cNvSpPr/>
-          <p:nvPr/>
-        </p:nvSpPr>
-        <p:spPr>
-          <a:xfrm>
-            <a:off x="5760720" y="640080"/>
-            <a:ext cx="6126480" cy="320040"/>
-          </a:xfrm>
-          <a:prstGeom prst="rect">
-            <a:avLst/>
-          </a:prstGeom>
-          <a:noFill/>
-          <a:ln/>
-        </p:spPr>
-        <p:txBody>
-          <a:bodyPr wrap="square" rtlCol="0" anchor="ctr"/>
-          <a:lstStyle/>
-          <a:p>
-            <a:pPr marL="0" indent="0">
-              <a:buNone/>
-            </a:pPr>
-            <a:r>
-              <a:rPr lang="en-US" sz="1200" b="1" dirty="0">
-                <a:solidFill>
-                  <a:srgbClr val="111848"/>
-                </a:solidFill>
-                <a:latin typeface="Arial" pitchFamily="34" charset="0"/>
-                <a:ea typeface="Arial" pitchFamily="34" charset="-122"/>
-                <a:cs typeface="Arial" pitchFamily="34" charset="-120"/>
-              </a:rPr>
-              <a:t>Cell 15: 실행 코드</a:t>
-            </a:r>
-            <a:endParaRPr lang="en-US" sz="1200" dirty="0"/>
-          </a:p>
-        </p:txBody>
-      </p:sp>
-      <p:sp>
-        <p:nvSpPr>
-          <p:cNvPr id="16" name="Shape 14"/>
-          <p:cNvSpPr/>
-          <p:nvPr/>
-        </p:nvSpPr>
-        <p:spPr>
-          <a:xfrm>
-            <a:off x="5760720" y="1005840"/>
-            <a:ext cx="6126480" cy="4014216"/>
-          </a:xfrm>
-          <a:prstGeom prst="rect">
-            <a:avLst/>
-          </a:prstGeom>
-          <a:solidFill>
-            <a:srgbClr val="0D1117"/>
-          </a:solidFill>
-          <a:ln/>
-          <a:effectLst>
-            <a:outerShdw blurRad="63500" dist="25400" dir="8100000" algn="bl" rotWithShape="0">
-              <a:srgbClr val="000000">
-                <a:alpha val="10000"/>
-              </a:srgbClr>
-            </a:outerShdw>
-          </a:effectLst>
-        </p:spPr>
-        <p:txBody>
-          <a:bodyPr/>
-          <a:lstStyle/>
-          <a:p>
-            <a:endParaRPr lang="ko-KR" altLang="en-US" dirty="0"/>
-          </a:p>
-        </p:txBody>
-      </p:sp>
-      <p:sp>
-        <p:nvSpPr>
-          <p:cNvPr id="17" name="Text 15"/>
-          <p:cNvSpPr/>
-          <p:nvPr/>
-        </p:nvSpPr>
-        <p:spPr>
-          <a:xfrm>
-            <a:off x="5897880" y="1115568"/>
-            <a:ext cx="5852160" cy="228600"/>
-          </a:xfrm>
-          <a:prstGeom prst="rect">
-            <a:avLst/>
-          </a:prstGeom>
-          <a:noFill/>
-          <a:ln/>
-        </p:spPr>
-        <p:txBody>
-          <a:bodyPr wrap="square" lIns="0" tIns="0" rIns="0" bIns="0" rtlCol="0" anchor="ctr"/>
-          <a:lstStyle/>
-          <a:p>
-            <a:pPr marL="0" indent="0">
-              <a:buNone/>
-            </a:pPr>
-            <a:r>
-              <a:rPr lang="en-US" sz="950" dirty="0">
-                <a:solidFill>
-                  <a:srgbClr val="E6EDF3"/>
-                </a:solidFill>
-                <a:latin typeface="Consolas" pitchFamily="34" charset="0"/>
-                <a:ea typeface="Consolas" pitchFamily="34" charset="-122"/>
-                <a:cs typeface="Consolas" pitchFamily="34" charset="-120"/>
-              </a:rPr>
-              <a:t>import json, glob</a:t>
-            </a:r>
-            <a:endParaRPr lang="en-US" sz="950" dirty="0"/>
-          </a:p>
-        </p:txBody>
-      </p:sp>
-      <p:sp>
-        <p:nvSpPr>
-          <p:cNvPr id="18" name="Text 16"/>
-          <p:cNvSpPr/>
-          <p:nvPr/>
-        </p:nvSpPr>
-        <p:spPr>
-          <a:xfrm>
-            <a:off x="5897880" y="1362456"/>
-            <a:ext cx="5852160" cy="228600"/>
-          </a:xfrm>
-          <a:prstGeom prst="rect">
-            <a:avLst/>
-          </a:prstGeom>
-          <a:noFill/>
-          <a:ln/>
-        </p:spPr>
-        <p:txBody>
-          <a:bodyPr wrap="square" lIns="0" tIns="0" rIns="0" bIns="0" rtlCol="0" anchor="ctr"/>
-          <a:lstStyle/>
-          <a:p>
-            <a:pPr marL="0" indent="0">
-              <a:buNone/>
-            </a:pPr>
-            <a:endParaRPr lang="en-US" sz="950" dirty="0"/>
-          </a:p>
-        </p:txBody>
-      </p:sp>
-      <p:sp>
-        <p:nvSpPr>
-          <p:cNvPr id="19" name="Text 17"/>
-          <p:cNvSpPr/>
-          <p:nvPr/>
-        </p:nvSpPr>
-        <p:spPr>
-          <a:xfrm>
-            <a:off x="5897880" y="1609344"/>
-            <a:ext cx="5852160" cy="228600"/>
-          </a:xfrm>
-          <a:prstGeom prst="rect">
-            <a:avLst/>
-          </a:prstGeom>
-          <a:noFill/>
-          <a:ln/>
-        </p:spPr>
-        <p:txBody>
-          <a:bodyPr wrap="square" lIns="0" tIns="0" rIns="0" bIns="0" rtlCol="0" anchor="ctr"/>
-          <a:lstStyle/>
-          <a:p>
-            <a:pPr marL="0" indent="0">
-              <a:buNone/>
-            </a:pPr>
-            <a:r>
-              <a:rPr lang="en-US" sz="950" dirty="0">
-                <a:solidFill>
-                  <a:srgbClr val="E6EDF3"/>
-                </a:solidFill>
-                <a:latin typeface="Consolas" pitchFamily="34" charset="0"/>
-                <a:ea typeface="Consolas" pitchFamily="34" charset="-122"/>
-                <a:cs typeface="Consolas" pitchFamily="34" charset="-120"/>
-              </a:rPr>
-              <a:t>run_files = sorted(glob.glob(</a:t>
-            </a:r>
-            <a:endParaRPr lang="en-US" sz="950" dirty="0"/>
-          </a:p>
-        </p:txBody>
-      </p:sp>
-      <p:sp>
-        <p:nvSpPr>
-          <p:cNvPr id="20" name="Text 18"/>
-          <p:cNvSpPr/>
-          <p:nvPr/>
-        </p:nvSpPr>
-        <p:spPr>
-          <a:xfrm>
-            <a:off x="5897880" y="1856232"/>
-            <a:ext cx="5852160" cy="228600"/>
-          </a:xfrm>
-          <a:prstGeom prst="rect">
-            <a:avLst/>
-          </a:prstGeom>
-          <a:noFill/>
-          <a:ln/>
-        </p:spPr>
-        <p:txBody>
-          <a:bodyPr wrap="square" lIns="0" tIns="0" rIns="0" bIns="0" rtlCol="0" anchor="ctr"/>
-          <a:lstStyle/>
-          <a:p>
-            <a:pPr marL="0" indent="0">
-              <a:buNone/>
-            </a:pPr>
-            <a:r>
-              <a:rPr lang="en-US" sz="950" dirty="0">
-                <a:solidFill>
-                  <a:srgbClr val="E6EDF3"/>
-                </a:solidFill>
-                <a:latin typeface="Consolas" pitchFamily="34" charset="0"/>
-                <a:ea typeface="Consolas" pitchFamily="34" charset="-122"/>
-                <a:cs typeface="Consolas" pitchFamily="34" charset="-120"/>
-              </a:rPr>
-              <a:t>    str(GARAK_RUNS / '*.report.jsonl')))</a:t>
-            </a:r>
-            <a:endParaRPr lang="en-US" sz="950" dirty="0"/>
-          </a:p>
-        </p:txBody>
-      </p:sp>
-      <p:sp>
-        <p:nvSpPr>
-          <p:cNvPr id="21" name="Text 19"/>
-          <p:cNvSpPr/>
-          <p:nvPr/>
-        </p:nvSpPr>
-        <p:spPr>
-          <a:xfrm>
-            <a:off x="5897880" y="2103120"/>
-            <a:ext cx="5852160" cy="228600"/>
-          </a:xfrm>
-          <a:prstGeom prst="rect">
-            <a:avLst/>
-          </a:prstGeom>
-          <a:noFill/>
-          <a:ln/>
-        </p:spPr>
-        <p:txBody>
-          <a:bodyPr wrap="square" lIns="0" tIns="0" rIns="0" bIns="0" rtlCol="0" anchor="ctr"/>
-          <a:lstStyle/>
-          <a:p>
-            <a:pPr marL="0" indent="0">
-              <a:buNone/>
-            </a:pPr>
-            <a:endParaRPr lang="en-US" sz="950" dirty="0"/>
-          </a:p>
-        </p:txBody>
-      </p:sp>
-      <p:sp>
-        <p:nvSpPr>
-          <p:cNvPr id="22" name="Text 20"/>
-          <p:cNvSpPr/>
-          <p:nvPr/>
-        </p:nvSpPr>
-        <p:spPr>
-          <a:xfrm>
-            <a:off x="5897880" y="2350008"/>
-            <a:ext cx="5852160" cy="228600"/>
-          </a:xfrm>
-          <a:prstGeom prst="rect">
-            <a:avLst/>
-          </a:prstGeom>
-          <a:noFill/>
-          <a:ln/>
-        </p:spPr>
-        <p:txBody>
-          <a:bodyPr wrap="square" lIns="0" tIns="0" rIns="0" bIns="0" rtlCol="0" anchor="ctr"/>
-          <a:lstStyle/>
-          <a:p>
-            <a:pPr marL="0" indent="0">
-              <a:buNone/>
-            </a:pPr>
-            <a:r>
-              <a:rPr lang="en-US" sz="950" dirty="0">
-                <a:solidFill>
-                  <a:srgbClr val="8B949E"/>
-                </a:solidFill>
-                <a:latin typeface="Consolas" pitchFamily="34" charset="0"/>
-                <a:ea typeface="Consolas" pitchFamily="34" charset="-122"/>
-                <a:cs typeface="Consolas" pitchFamily="34" charset="-120"/>
-              </a:rPr>
-              <a:t># 최신 리포트에서 eval 엔트리 추출</a:t>
-            </a:r>
-            <a:endParaRPr lang="en-US" sz="950" dirty="0"/>
-          </a:p>
-        </p:txBody>
-      </p:sp>
-      <p:sp>
-        <p:nvSpPr>
-          <p:cNvPr id="23" name="Text 21"/>
-          <p:cNvSpPr/>
-          <p:nvPr/>
-        </p:nvSpPr>
-        <p:spPr>
-          <a:xfrm>
-            <a:off x="5897880" y="2596896"/>
-            <a:ext cx="5852160" cy="228600"/>
-          </a:xfrm>
-          <a:prstGeom prst="rect">
-            <a:avLst/>
-          </a:prstGeom>
-          <a:noFill/>
-          <a:ln/>
-        </p:spPr>
-        <p:txBody>
-          <a:bodyPr wrap="square" lIns="0" tIns="0" rIns="0" bIns="0" rtlCol="0" anchor="ctr"/>
-          <a:lstStyle/>
-          <a:p>
-            <a:pPr marL="0" indent="0">
-              <a:buNone/>
-            </a:pPr>
-            <a:r>
-              <a:rPr lang="en-US" sz="950" dirty="0">
-                <a:solidFill>
-                  <a:srgbClr val="E6EDF3"/>
-                </a:solidFill>
-                <a:latin typeface="Consolas" pitchFamily="34" charset="0"/>
-                <a:ea typeface="Consolas" pitchFamily="34" charset="-122"/>
-                <a:cs typeface="Consolas" pitchFamily="34" charset="-120"/>
-              </a:rPr>
-              <a:t>target_report = max(</a:t>
-            </a:r>
-            <a:r>
-              <a:rPr lang="en-US" sz="950" dirty="0" err="1">
-                <a:solidFill>
-                  <a:srgbClr val="E6EDF3"/>
-                </a:solidFill>
-                <a:latin typeface="Consolas" pitchFamily="34" charset="0"/>
-                <a:ea typeface="Consolas" pitchFamily="34" charset="-122"/>
-                <a:cs typeface="Consolas" pitchFamily="34" charset="-120"/>
-              </a:rPr>
-              <a:t>run_files</a:t>
-            </a:r>
-            <a:r>
-              <a:rPr lang="en-US" sz="950" dirty="0">
-                <a:solidFill>
-                  <a:srgbClr val="E6EDF3"/>
-                </a:solidFill>
-                <a:latin typeface="Consolas" pitchFamily="34" charset="0"/>
-                <a:ea typeface="Consolas" pitchFamily="34" charset="-122"/>
-                <a:cs typeface="Consolas" pitchFamily="34" charset="-120"/>
-              </a:rPr>
-              <a:t>, key=</a:t>
-            </a:r>
-            <a:r>
-              <a:rPr lang="en-US" sz="950" dirty="0" err="1">
-                <a:solidFill>
-                  <a:srgbClr val="E6EDF3"/>
-                </a:solidFill>
-                <a:latin typeface="Consolas" pitchFamily="34" charset="0"/>
-                <a:ea typeface="Consolas" pitchFamily="34" charset="-122"/>
-                <a:cs typeface="Consolas" pitchFamily="34" charset="-120"/>
-              </a:rPr>
-              <a:t>os.path.getmtime</a:t>
-            </a:r>
-            <a:r>
-              <a:rPr lang="en-US" sz="950" dirty="0">
-                <a:solidFill>
-                  <a:srgbClr val="E6EDF3"/>
-                </a:solidFill>
-                <a:latin typeface="Consolas" pitchFamily="34" charset="0"/>
-                <a:ea typeface="Consolas" pitchFamily="34" charset="-122"/>
-                <a:cs typeface="Consolas" pitchFamily="34" charset="-120"/>
-              </a:rPr>
-              <a:t>)</a:t>
-            </a:r>
-            <a:endParaRPr lang="en-US" sz="950" dirty="0"/>
-          </a:p>
-        </p:txBody>
-      </p:sp>
-      <p:sp>
-        <p:nvSpPr>
-          <p:cNvPr id="24" name="Text 22"/>
-          <p:cNvSpPr/>
-          <p:nvPr/>
-        </p:nvSpPr>
-        <p:spPr>
-          <a:xfrm>
-            <a:off x="5897880" y="2843784"/>
-            <a:ext cx="5852160" cy="228600"/>
-          </a:xfrm>
-          <a:prstGeom prst="rect">
-            <a:avLst/>
-          </a:prstGeom>
-          <a:noFill/>
-          <a:ln/>
-        </p:spPr>
-        <p:txBody>
-          <a:bodyPr wrap="square" lIns="0" tIns="0" rIns="0" bIns="0" rtlCol="0" anchor="ctr"/>
-          <a:lstStyle/>
-          <a:p>
-            <a:pPr marL="0" indent="0">
-              <a:buNone/>
-            </a:pPr>
-            <a:r>
-              <a:rPr lang="en-US" sz="950" dirty="0">
-                <a:solidFill>
-                  <a:srgbClr val="E6EDF3"/>
-                </a:solidFill>
-                <a:latin typeface="Consolas" pitchFamily="34" charset="0"/>
-                <a:ea typeface="Consolas" pitchFamily="34" charset="-122"/>
-                <a:cs typeface="Consolas" pitchFamily="34" charset="-120"/>
-              </a:rPr>
-              <a:t>print(f"{'</a:t>
-            </a:r>
-            <a:r>
-              <a:rPr lang="ko-KR" altLang="en-US" sz="950" dirty="0">
-                <a:solidFill>
-                  <a:srgbClr val="E6EDF3"/>
-                </a:solidFill>
-                <a:latin typeface="Consolas" pitchFamily="34" charset="0"/>
-                <a:ea typeface="Consolas" pitchFamily="34" charset="-122"/>
-                <a:cs typeface="Consolas" pitchFamily="34" charset="-120"/>
-              </a:rPr>
-              <a:t>공격 유형</a:t>
-            </a:r>
-            <a:r>
-              <a:rPr lang="en-US" altLang="ko-KR" sz="950" dirty="0">
-                <a:solidFill>
-                  <a:srgbClr val="E6EDF3"/>
-                </a:solidFill>
-                <a:latin typeface="Consolas" pitchFamily="34" charset="0"/>
-                <a:ea typeface="Consolas" pitchFamily="34" charset="-122"/>
-                <a:cs typeface="Consolas" pitchFamily="34" charset="-120"/>
-              </a:rPr>
-              <a:t>(</a:t>
-            </a:r>
-            <a:r>
-              <a:rPr lang="en-US" sz="950" dirty="0">
-                <a:solidFill>
-                  <a:srgbClr val="E6EDF3"/>
-                </a:solidFill>
-                <a:latin typeface="Consolas" pitchFamily="34" charset="0"/>
-                <a:ea typeface="Consolas" pitchFamily="34" charset="-122"/>
-                <a:cs typeface="Consolas" pitchFamily="34" charset="-120"/>
-              </a:rPr>
-              <a:t>Probe)':&lt;30} | {'</a:t>
-            </a:r>
-            <a:r>
-              <a:rPr lang="ko-KR" altLang="en-US" sz="950" dirty="0">
-                <a:solidFill>
-                  <a:srgbClr val="E6EDF3"/>
-                </a:solidFill>
-                <a:latin typeface="Consolas" pitchFamily="34" charset="0"/>
-                <a:ea typeface="Consolas" pitchFamily="34" charset="-122"/>
-                <a:cs typeface="Consolas" pitchFamily="34" charset="-120"/>
-              </a:rPr>
-              <a:t>검사기</a:t>
-            </a:r>
-            <a:r>
-              <a:rPr lang="en-US" altLang="ko-KR" sz="950" dirty="0">
-                <a:solidFill>
-                  <a:srgbClr val="E6EDF3"/>
-                </a:solidFill>
-                <a:latin typeface="Consolas" pitchFamily="34" charset="0"/>
-                <a:ea typeface="Consolas" pitchFamily="34" charset="-122"/>
-                <a:cs typeface="Consolas" pitchFamily="34" charset="-120"/>
-              </a:rPr>
-              <a:t>(</a:t>
-            </a:r>
-            <a:r>
-              <a:rPr lang="en-US" sz="950" dirty="0">
-                <a:solidFill>
-                  <a:srgbClr val="E6EDF3"/>
-                </a:solidFill>
-                <a:latin typeface="Consolas" pitchFamily="34" charset="0"/>
-                <a:ea typeface="Consolas" pitchFamily="34" charset="-122"/>
-                <a:cs typeface="Consolas" pitchFamily="34" charset="-120"/>
-              </a:rPr>
-              <a:t>Detector)':&lt;40} | {'</a:t>
-            </a:r>
-            <a:r>
-              <a:rPr lang="ko-KR" altLang="en-US" sz="950" dirty="0">
-                <a:solidFill>
-                  <a:srgbClr val="E6EDF3"/>
-                </a:solidFill>
-                <a:latin typeface="Consolas" pitchFamily="34" charset="0"/>
-                <a:ea typeface="Consolas" pitchFamily="34" charset="-122"/>
-                <a:cs typeface="Consolas" pitchFamily="34" charset="-120"/>
-              </a:rPr>
-              <a:t>결과</a:t>
-            </a:r>
-            <a:r>
-              <a:rPr lang="en-US" altLang="ko-KR" sz="950" dirty="0">
-                <a:solidFill>
-                  <a:srgbClr val="E6EDF3"/>
-                </a:solidFill>
-                <a:latin typeface="Consolas" pitchFamily="34" charset="0"/>
-                <a:ea typeface="Consolas" pitchFamily="34" charset="-122"/>
-                <a:cs typeface="Consolas" pitchFamily="34" charset="-120"/>
-              </a:rPr>
-              <a:t>'}")</a:t>
-            </a:r>
-          </a:p>
-        </p:txBody>
-      </p:sp>
-      <p:sp>
-        <p:nvSpPr>
-          <p:cNvPr id="29" name="Text 27"/>
-          <p:cNvSpPr/>
-          <p:nvPr/>
-        </p:nvSpPr>
-        <p:spPr>
-          <a:xfrm>
-            <a:off x="5897880" y="3306682"/>
-            <a:ext cx="5852160" cy="228600"/>
-          </a:xfrm>
-          <a:prstGeom prst="rect">
-            <a:avLst/>
-          </a:prstGeom>
-          <a:noFill/>
-          <a:ln/>
-        </p:spPr>
-        <p:txBody>
-          <a:bodyPr wrap="square" lIns="0" tIns="0" rIns="0" bIns="0" rtlCol="0" anchor="ctr"/>
-          <a:lstStyle/>
-          <a:p>
-            <a:pPr marL="0" indent="0">
-              <a:buNone/>
-            </a:pPr>
-            <a:r>
-              <a:rPr lang="en-US" sz="950" dirty="0">
-                <a:solidFill>
-                  <a:srgbClr val="8B949E"/>
-                </a:solidFill>
-                <a:latin typeface="Consolas" pitchFamily="34" charset="0"/>
-                <a:ea typeface="Consolas" pitchFamily="34" charset="-122"/>
-                <a:cs typeface="Consolas" pitchFamily="34" charset="-120"/>
-              </a:rPr>
-              <a:t># </a:t>
-            </a:r>
-            <a:r>
-              <a:rPr lang="ko-KR" altLang="en-US" sz="950" dirty="0">
-                <a:solidFill>
-                  <a:srgbClr val="8B949E"/>
-                </a:solidFill>
-                <a:latin typeface="Consolas" pitchFamily="34" charset="0"/>
-                <a:ea typeface="Consolas" pitchFamily="34" charset="-122"/>
-                <a:cs typeface="Consolas" pitchFamily="34" charset="-120"/>
-              </a:rPr>
-              <a:t>선택된 단일파일의 </a:t>
-            </a:r>
-            <a:r>
-              <a:rPr lang="en-US" altLang="ko-KR" sz="950" dirty="0">
-                <a:solidFill>
-                  <a:srgbClr val="8B949E"/>
-                </a:solidFill>
-                <a:latin typeface="Consolas" pitchFamily="34" charset="0"/>
-                <a:ea typeface="Consolas" pitchFamily="34" charset="-122"/>
-                <a:cs typeface="Consolas" pitchFamily="34" charset="-120"/>
-              </a:rPr>
-              <a:t>‘eval’ </a:t>
-            </a:r>
-            <a:r>
-              <a:rPr lang="ko-KR" altLang="en-US" sz="950" dirty="0">
-                <a:solidFill>
-                  <a:srgbClr val="8B949E"/>
-                </a:solidFill>
-                <a:latin typeface="Consolas" pitchFamily="34" charset="0"/>
-                <a:ea typeface="Consolas" pitchFamily="34" charset="-122"/>
-                <a:cs typeface="Consolas" pitchFamily="34" charset="-120"/>
-              </a:rPr>
-              <a:t>엔트리만 </a:t>
-            </a:r>
-            <a:r>
-              <a:rPr lang="ko-KR" altLang="en-US" sz="950" dirty="0" err="1">
-                <a:solidFill>
-                  <a:srgbClr val="8B949E"/>
-                </a:solidFill>
-                <a:latin typeface="Consolas" pitchFamily="34" charset="0"/>
-                <a:ea typeface="Consolas" pitchFamily="34" charset="-122"/>
-                <a:cs typeface="Consolas" pitchFamily="34" charset="-120"/>
-              </a:rPr>
-              <a:t>파싱하여</a:t>
-            </a:r>
-            <a:r>
-              <a:rPr lang="ko-KR" altLang="en-US" sz="950" dirty="0">
-                <a:solidFill>
-                  <a:srgbClr val="8B949E"/>
-                </a:solidFill>
-                <a:latin typeface="Consolas" pitchFamily="34" charset="0"/>
-                <a:ea typeface="Consolas" pitchFamily="34" charset="-122"/>
-                <a:cs typeface="Consolas" pitchFamily="34" charset="-120"/>
-              </a:rPr>
-              <a:t> 출력</a:t>
-            </a:r>
-            <a:endParaRPr lang="en-US" sz="950" dirty="0"/>
-          </a:p>
-        </p:txBody>
-      </p:sp>
-      <p:sp>
-        <p:nvSpPr>
-          <p:cNvPr id="30" name="Text 28"/>
-          <p:cNvSpPr/>
-          <p:nvPr/>
-        </p:nvSpPr>
-        <p:spPr>
-          <a:xfrm>
-            <a:off x="5897880" y="3553569"/>
-            <a:ext cx="5852160" cy="1879821"/>
-          </a:xfrm>
-          <a:prstGeom prst="rect">
-            <a:avLst/>
-          </a:prstGeom>
-          <a:noFill/>
-          <a:ln/>
-        </p:spPr>
-        <p:txBody>
-          <a:bodyPr wrap="square" lIns="0" tIns="0" rIns="0" bIns="0" rtlCol="0" anchor="t"/>
-          <a:lstStyle/>
-          <a:p>
-            <a:pPr marL="0" indent="0">
-              <a:buNone/>
-            </a:pPr>
-            <a:r>
-              <a:rPr lang="es-419" altLang="ko-KR" sz="950" dirty="0">
-                <a:solidFill>
-                  <a:srgbClr val="E6EDF3"/>
-                </a:solidFill>
-                <a:latin typeface="Consolas" pitchFamily="34" charset="0"/>
-                <a:ea typeface="Consolas" pitchFamily="34" charset="-122"/>
-                <a:cs typeface="Consolas" pitchFamily="34" charset="-120"/>
-              </a:rPr>
-              <a:t>with open(target_report, 'r') as f:</a:t>
-            </a:r>
-          </a:p>
-          <a:p>
-            <a:pPr marL="0" indent="0">
-              <a:buNone/>
-            </a:pPr>
-            <a:r>
-              <a:rPr lang="ko-KR" altLang="en-US" sz="950" dirty="0">
-                <a:solidFill>
-                  <a:srgbClr val="E6EDF3"/>
-                </a:solidFill>
-                <a:latin typeface="Consolas" pitchFamily="34" charset="0"/>
-                <a:ea typeface="Consolas" pitchFamily="34" charset="-122"/>
-                <a:cs typeface="Consolas" pitchFamily="34" charset="-120"/>
-              </a:rPr>
-              <a:t>    </a:t>
-            </a:r>
-            <a:r>
-              <a:rPr lang="es-419" altLang="ko-KR" sz="950" dirty="0">
-                <a:solidFill>
-                  <a:srgbClr val="E6EDF3"/>
-                </a:solidFill>
-                <a:latin typeface="Consolas" pitchFamily="34" charset="0"/>
-                <a:ea typeface="Consolas" pitchFamily="34" charset="-122"/>
-                <a:cs typeface="Consolas" pitchFamily="34" charset="-120"/>
-              </a:rPr>
-              <a:t>for line in f:</a:t>
-            </a:r>
-          </a:p>
-          <a:p>
-            <a:pPr marL="0" indent="0">
-              <a:buNone/>
-            </a:pPr>
-            <a:r>
-              <a:rPr lang="ko-KR" altLang="en-US" sz="950" dirty="0">
-                <a:solidFill>
-                  <a:srgbClr val="E6EDF3"/>
-                </a:solidFill>
-                <a:latin typeface="Consolas" pitchFamily="34" charset="0"/>
-                <a:ea typeface="Consolas" pitchFamily="34" charset="-122"/>
-                <a:cs typeface="Consolas" pitchFamily="34" charset="-120"/>
-              </a:rPr>
-              <a:t>        </a:t>
-            </a:r>
-            <a:r>
-              <a:rPr lang="es-419" altLang="ko-KR" sz="950" dirty="0">
-                <a:solidFill>
-                  <a:srgbClr val="E6EDF3"/>
-                </a:solidFill>
-                <a:latin typeface="Consolas" pitchFamily="34" charset="0"/>
-                <a:ea typeface="Consolas" pitchFamily="34" charset="-122"/>
-                <a:cs typeface="Consolas" pitchFamily="34" charset="-120"/>
-              </a:rPr>
-              <a:t>data = json.loads(line)</a:t>
-            </a:r>
-          </a:p>
-          <a:p>
-            <a:pPr marL="0" indent="0">
-              <a:buNone/>
-            </a:pPr>
-            <a:r>
-              <a:rPr lang="ko-KR" altLang="en-US" sz="950" dirty="0">
-                <a:solidFill>
-                  <a:srgbClr val="E6EDF3"/>
-                </a:solidFill>
-                <a:latin typeface="Consolas" pitchFamily="34" charset="0"/>
-                <a:ea typeface="Consolas" pitchFamily="34" charset="-122"/>
-                <a:cs typeface="Consolas" pitchFamily="34" charset="-120"/>
-              </a:rPr>
-              <a:t>        </a:t>
-            </a:r>
-            <a:r>
-              <a:rPr lang="es-419" altLang="ko-KR" sz="950" dirty="0">
-                <a:solidFill>
-                  <a:srgbClr val="E6EDF3"/>
-                </a:solidFill>
-                <a:latin typeface="Consolas" pitchFamily="34" charset="0"/>
-                <a:ea typeface="Consolas" pitchFamily="34" charset="-122"/>
-                <a:cs typeface="Consolas" pitchFamily="34" charset="-120"/>
-              </a:rPr>
-              <a:t>if</a:t>
-            </a:r>
-            <a:r>
-              <a:rPr lang="en-US" altLang="ko-KR" sz="950" dirty="0">
-                <a:solidFill>
-                  <a:srgbClr val="E6EDF3"/>
-                </a:solidFill>
-                <a:latin typeface="Consolas" pitchFamily="34" charset="0"/>
-                <a:ea typeface="Consolas" pitchFamily="34" charset="-122"/>
-                <a:cs typeface="Consolas" pitchFamily="34" charset="-120"/>
-              </a:rPr>
-              <a:t> </a:t>
-            </a:r>
-            <a:r>
-              <a:rPr lang="es-419" altLang="ko-KR" sz="950" dirty="0">
-                <a:solidFill>
-                  <a:srgbClr val="E6EDF3"/>
-                </a:solidFill>
-                <a:latin typeface="Consolas" pitchFamily="34" charset="0"/>
-                <a:ea typeface="Consolas" pitchFamily="34" charset="-122"/>
-                <a:cs typeface="Consolas" pitchFamily="34" charset="-120"/>
-              </a:rPr>
-              <a:t>data.get('entry_type') == 'eval＇:</a:t>
-            </a:r>
-          </a:p>
-          <a:p>
-            <a:pPr marL="0" indent="0">
-              <a:buNone/>
-            </a:pPr>
-            <a:r>
-              <a:rPr lang="ko-KR" altLang="en-US" sz="950" dirty="0">
-                <a:solidFill>
-                  <a:srgbClr val="E6EDF3"/>
-                </a:solidFill>
-                <a:latin typeface="Consolas" pitchFamily="34" charset="0"/>
-                <a:ea typeface="Consolas" pitchFamily="34" charset="-122"/>
-                <a:cs typeface="Consolas" pitchFamily="34" charset="-120"/>
-              </a:rPr>
-              <a:t>            </a:t>
-            </a:r>
-            <a:r>
-              <a:rPr lang="es-419" altLang="ko-KR" sz="950" dirty="0">
-                <a:solidFill>
-                  <a:srgbClr val="E6EDF3"/>
-                </a:solidFill>
-                <a:latin typeface="Consolas" pitchFamily="34" charset="0"/>
-                <a:ea typeface="Consolas" pitchFamily="34" charset="-122"/>
-                <a:cs typeface="Consolas" pitchFamily="34" charset="-120"/>
-              </a:rPr>
-              <a:t>status</a:t>
-            </a:r>
-            <a:r>
-              <a:rPr lang="en-US" altLang="ko-KR" sz="950" dirty="0">
-                <a:solidFill>
-                  <a:srgbClr val="E6EDF3"/>
-                </a:solidFill>
-                <a:latin typeface="Consolas" pitchFamily="34" charset="0"/>
-                <a:ea typeface="Consolas" pitchFamily="34" charset="-122"/>
-                <a:cs typeface="Consolas" pitchFamily="34" charset="-120"/>
-              </a:rPr>
-              <a:t> </a:t>
-            </a:r>
-            <a:r>
-              <a:rPr lang="es-419" altLang="ko-KR" sz="950" dirty="0">
-                <a:solidFill>
-                  <a:srgbClr val="E6EDF3"/>
-                </a:solidFill>
-                <a:latin typeface="Consolas" pitchFamily="34" charset="0"/>
-                <a:ea typeface="Consolas" pitchFamily="34" charset="-122"/>
-                <a:cs typeface="Consolas" pitchFamily="34" charset="-120"/>
-              </a:rPr>
-              <a:t>= 'FAIL' if data['fails'] &gt; 0 else 'PASS＇</a:t>
-            </a:r>
-          </a:p>
-          <a:p>
-            <a:pPr marL="0" indent="0">
-              <a:buNone/>
-            </a:pPr>
-            <a:r>
-              <a:rPr lang="ko-KR" altLang="en-US" sz="950" dirty="0">
-                <a:solidFill>
-                  <a:srgbClr val="E6EDF3"/>
-                </a:solidFill>
-                <a:latin typeface="Consolas" pitchFamily="34" charset="0"/>
-                <a:ea typeface="Consolas" pitchFamily="34" charset="-122"/>
-                <a:cs typeface="Consolas" pitchFamily="34" charset="-120"/>
-              </a:rPr>
-              <a:t>            </a:t>
-            </a:r>
-            <a:r>
-              <a:rPr lang="es-419" altLang="ko-KR" sz="950" dirty="0">
-                <a:solidFill>
-                  <a:srgbClr val="E6EDF3"/>
-                </a:solidFill>
-                <a:latin typeface="Consolas" pitchFamily="34" charset="0"/>
-                <a:ea typeface="Consolas" pitchFamily="34" charset="-122"/>
-                <a:cs typeface="Consolas" pitchFamily="34" charset="-120"/>
-              </a:rPr>
-              <a:t>probe = data['probe＇]</a:t>
-            </a:r>
-            <a:r>
-              <a:rPr lang="ko-KR" altLang="en-US" sz="950" dirty="0">
-                <a:solidFill>
-                  <a:srgbClr val="E6EDF3"/>
-                </a:solidFill>
-                <a:latin typeface="Consolas" pitchFamily="34" charset="0"/>
-                <a:ea typeface="Consolas" pitchFamily="34" charset="-122"/>
-                <a:cs typeface="Consolas" pitchFamily="34" charset="-120"/>
-              </a:rPr>
-              <a:t>   </a:t>
-            </a:r>
-            <a:endParaRPr lang="es-419" altLang="ko-KR" sz="950" dirty="0">
-              <a:solidFill>
-                <a:srgbClr val="E6EDF3"/>
-              </a:solidFill>
-              <a:latin typeface="Consolas" pitchFamily="34" charset="0"/>
-              <a:ea typeface="Consolas" pitchFamily="34" charset="-122"/>
-              <a:cs typeface="Consolas" pitchFamily="34" charset="-120"/>
-            </a:endParaRPr>
-          </a:p>
-          <a:p>
-            <a:pPr marL="0" indent="0">
-              <a:buNone/>
-            </a:pPr>
-            <a:r>
-              <a:rPr lang="ko-KR" altLang="en-US" sz="950" dirty="0">
-                <a:solidFill>
-                  <a:srgbClr val="E6EDF3"/>
-                </a:solidFill>
-                <a:latin typeface="Consolas" pitchFamily="34" charset="0"/>
-                <a:ea typeface="Consolas" pitchFamily="34" charset="-122"/>
-                <a:cs typeface="Consolas" pitchFamily="34" charset="-120"/>
-              </a:rPr>
-              <a:t>           </a:t>
-            </a:r>
-            <a:r>
-              <a:rPr lang="en-US" altLang="ko-KR" sz="950" dirty="0">
-                <a:solidFill>
-                  <a:srgbClr val="E6EDF3"/>
-                </a:solidFill>
-                <a:latin typeface="Consolas" pitchFamily="34" charset="0"/>
-                <a:ea typeface="Consolas" pitchFamily="34" charset="-122"/>
-                <a:cs typeface="Consolas" pitchFamily="34" charset="-120"/>
-              </a:rPr>
-              <a:t> d</a:t>
-            </a:r>
-            <a:r>
-              <a:rPr lang="es-419" altLang="ko-KR" sz="950" dirty="0">
-                <a:solidFill>
-                  <a:srgbClr val="E6EDF3"/>
-                </a:solidFill>
-                <a:latin typeface="Consolas" pitchFamily="34" charset="0"/>
-                <a:ea typeface="Consolas" pitchFamily="34" charset="-122"/>
-                <a:cs typeface="Consolas" pitchFamily="34" charset="-120"/>
-              </a:rPr>
-              <a:t>etector = data['detector’]</a:t>
-            </a:r>
-          </a:p>
-          <a:p>
-            <a:pPr marL="0" indent="0">
-              <a:buNone/>
-            </a:pPr>
-            <a:r>
-              <a:rPr lang="es-419" altLang="ko-KR" sz="950" dirty="0">
-                <a:solidFill>
-                  <a:srgbClr val="E6EDF3"/>
-                </a:solidFill>
-                <a:latin typeface="Consolas" pitchFamily="34" charset="0"/>
-                <a:ea typeface="Consolas" pitchFamily="34" charset="-122"/>
-                <a:cs typeface="Consolas" pitchFamily="34" charset="-120"/>
-              </a:rPr>
-              <a:t>            print(f"{probe:&lt;30} | {detector:&lt;40} | {status}")</a:t>
-            </a:r>
-          </a:p>
-        </p:txBody>
-      </p:sp>
-      <p:sp>
-        <p:nvSpPr>
-          <p:cNvPr id="39" name="Text 37"/>
-          <p:cNvSpPr/>
-          <p:nvPr/>
-        </p:nvSpPr>
-        <p:spPr>
-          <a:xfrm>
-            <a:off x="11064240" y="6510528"/>
-            <a:ext cx="914400" cy="274320"/>
-          </a:xfrm>
-          <a:prstGeom prst="rect">
-            <a:avLst/>
-          </a:prstGeom>
-          <a:noFill/>
-          <a:ln/>
-        </p:spPr>
-        <p:txBody>
-          <a:bodyPr wrap="square" lIns="0" tIns="0" rIns="0" bIns="0" rtlCol="0" anchor="ctr"/>
-          <a:lstStyle/>
-          <a:p>
-            <a:pPr marL="0" indent="0" algn="r">
-              <a:buNone/>
-            </a:pPr>
-            <a:r>
-              <a:rPr lang="en-US" sz="900" dirty="0">
-                <a:solidFill>
-                  <a:srgbClr val="94A3B8"/>
-                </a:solidFill>
-                <a:latin typeface="Arial" pitchFamily="34" charset="0"/>
-                <a:ea typeface="Arial" pitchFamily="34" charset="-122"/>
-                <a:cs typeface="Arial" pitchFamily="34" charset="-120"/>
-              </a:rPr>
-              <a:t>9 / 19</a:t>
             </a:r>
             <a:endParaRPr lang="en-US" sz="900" dirty="0"/>
           </a:p>

</xml_diff>